<commit_message>
Presentation updated + played around with visualization
dropped the drafted people, looked for monotone relationship, made presentation more bonita
</commit_message>
<xml_diff>
--- a/phase_1/KDDM_phase1_presentation.pptx
+++ b/phase_1/KDDM_phase1_presentation.pptx
@@ -16,6 +16,9 @@
     <p:sldId id="261" r:id="rId13"/>
     <p:sldId id="262" r:id="rId14"/>
     <p:sldId id="263" r:id="rId15"/>
+    <p:sldId id="264" r:id="rId16"/>
+    <p:sldId id="265" r:id="rId17"/>
+    <p:sldId id="266" r:id="rId18"/>
   </p:sldIdLst>
   <p:sldSz cx="12928600" cy="7315200"/>
   <p:notesSz cx="6858000" cy="9144000"/>
@@ -70,13 +73,13 @@
         </a:solidFill>
         <a:effectLst/>
         <a:uFillTx/>
-        <a:latin typeface="Arial"/>
-        <a:ea typeface="Arial"/>
-        <a:cs typeface="Arial"/>
-        <a:sym typeface="Arial"/>
+        <a:latin typeface="+mn-lt"/>
+        <a:ea typeface="+mn-ea"/>
+        <a:cs typeface="+mn-cs"/>
+        <a:sym typeface="Helvetica"/>
       </a:defRPr>
     </a:lvl1pPr>
-    <a:lvl2pPr marL="0" marR="0" indent="648080" algn="l" defTabSz="648080" rtl="0" fontAlgn="auto" latinLnBrk="0" hangingPunct="0">
+    <a:lvl2pPr marL="0" marR="0" indent="0" algn="l" defTabSz="648080" rtl="0" fontAlgn="auto" latinLnBrk="0" hangingPunct="0">
       <a:lnSpc>
         <a:spcPct val="100000"/>
       </a:lnSpc>
@@ -100,13 +103,13 @@
         </a:solidFill>
         <a:effectLst/>
         <a:uFillTx/>
-        <a:latin typeface="Arial"/>
-        <a:ea typeface="Arial"/>
-        <a:cs typeface="Arial"/>
-        <a:sym typeface="Arial"/>
+        <a:latin typeface="+mn-lt"/>
+        <a:ea typeface="+mn-ea"/>
+        <a:cs typeface="+mn-cs"/>
+        <a:sym typeface="Helvetica"/>
       </a:defRPr>
     </a:lvl2pPr>
-    <a:lvl3pPr marL="0" marR="0" indent="1296161" algn="l" defTabSz="648080" rtl="0" fontAlgn="auto" latinLnBrk="0" hangingPunct="0">
+    <a:lvl3pPr marL="0" marR="0" indent="0" algn="l" defTabSz="648080" rtl="0" fontAlgn="auto" latinLnBrk="0" hangingPunct="0">
       <a:lnSpc>
         <a:spcPct val="100000"/>
       </a:lnSpc>
@@ -130,13 +133,13 @@
         </a:solidFill>
         <a:effectLst/>
         <a:uFillTx/>
-        <a:latin typeface="Arial"/>
-        <a:ea typeface="Arial"/>
-        <a:cs typeface="Arial"/>
-        <a:sym typeface="Arial"/>
+        <a:latin typeface="+mn-lt"/>
+        <a:ea typeface="+mn-ea"/>
+        <a:cs typeface="+mn-cs"/>
+        <a:sym typeface="Helvetica"/>
       </a:defRPr>
     </a:lvl3pPr>
-    <a:lvl4pPr marL="0" marR="0" indent="1944242" algn="l" defTabSz="648080" rtl="0" fontAlgn="auto" latinLnBrk="0" hangingPunct="0">
+    <a:lvl4pPr marL="0" marR="0" indent="0" algn="l" defTabSz="648080" rtl="0" fontAlgn="auto" latinLnBrk="0" hangingPunct="0">
       <a:lnSpc>
         <a:spcPct val="100000"/>
       </a:lnSpc>
@@ -160,13 +163,13 @@
         </a:solidFill>
         <a:effectLst/>
         <a:uFillTx/>
-        <a:latin typeface="Arial"/>
-        <a:ea typeface="Arial"/>
-        <a:cs typeface="Arial"/>
-        <a:sym typeface="Arial"/>
+        <a:latin typeface="+mn-lt"/>
+        <a:ea typeface="+mn-ea"/>
+        <a:cs typeface="+mn-cs"/>
+        <a:sym typeface="Helvetica"/>
       </a:defRPr>
     </a:lvl4pPr>
-    <a:lvl5pPr marL="0" marR="0" indent="2592323" algn="l" defTabSz="648080" rtl="0" fontAlgn="auto" latinLnBrk="0" hangingPunct="0">
+    <a:lvl5pPr marL="0" marR="0" indent="0" algn="l" defTabSz="648080" rtl="0" fontAlgn="auto" latinLnBrk="0" hangingPunct="0">
       <a:lnSpc>
         <a:spcPct val="100000"/>
       </a:lnSpc>
@@ -190,13 +193,13 @@
         </a:solidFill>
         <a:effectLst/>
         <a:uFillTx/>
-        <a:latin typeface="Arial"/>
-        <a:ea typeface="Arial"/>
-        <a:cs typeface="Arial"/>
-        <a:sym typeface="Arial"/>
+        <a:latin typeface="+mn-lt"/>
+        <a:ea typeface="+mn-ea"/>
+        <a:cs typeface="+mn-cs"/>
+        <a:sym typeface="Helvetica"/>
       </a:defRPr>
     </a:lvl5pPr>
-    <a:lvl6pPr marL="0" marR="0" indent="3240404" algn="l" defTabSz="648080" rtl="0" fontAlgn="auto" latinLnBrk="0" hangingPunct="0">
+    <a:lvl6pPr marL="0" marR="0" indent="0" algn="l" defTabSz="648080" rtl="0" fontAlgn="auto" latinLnBrk="0" hangingPunct="0">
       <a:lnSpc>
         <a:spcPct val="100000"/>
       </a:lnSpc>
@@ -220,13 +223,13 @@
         </a:solidFill>
         <a:effectLst/>
         <a:uFillTx/>
-        <a:latin typeface="Arial"/>
-        <a:ea typeface="Arial"/>
-        <a:cs typeface="Arial"/>
-        <a:sym typeface="Arial"/>
+        <a:latin typeface="+mn-lt"/>
+        <a:ea typeface="+mn-ea"/>
+        <a:cs typeface="+mn-cs"/>
+        <a:sym typeface="Helvetica"/>
       </a:defRPr>
     </a:lvl6pPr>
-    <a:lvl7pPr marL="0" marR="0" indent="3888485" algn="l" defTabSz="648080" rtl="0" fontAlgn="auto" latinLnBrk="0" hangingPunct="0">
+    <a:lvl7pPr marL="0" marR="0" indent="0" algn="l" defTabSz="648080" rtl="0" fontAlgn="auto" latinLnBrk="0" hangingPunct="0">
       <a:lnSpc>
         <a:spcPct val="100000"/>
       </a:lnSpc>
@@ -250,13 +253,13 @@
         </a:solidFill>
         <a:effectLst/>
         <a:uFillTx/>
-        <a:latin typeface="Arial"/>
-        <a:ea typeface="Arial"/>
-        <a:cs typeface="Arial"/>
-        <a:sym typeface="Arial"/>
+        <a:latin typeface="+mn-lt"/>
+        <a:ea typeface="+mn-ea"/>
+        <a:cs typeface="+mn-cs"/>
+        <a:sym typeface="Helvetica"/>
       </a:defRPr>
     </a:lvl7pPr>
-    <a:lvl8pPr marL="0" marR="0" indent="4536566" algn="l" defTabSz="648080" rtl="0" fontAlgn="auto" latinLnBrk="0" hangingPunct="0">
+    <a:lvl8pPr marL="0" marR="0" indent="0" algn="l" defTabSz="648080" rtl="0" fontAlgn="auto" latinLnBrk="0" hangingPunct="0">
       <a:lnSpc>
         <a:spcPct val="100000"/>
       </a:lnSpc>
@@ -280,13 +283,13 @@
         </a:solidFill>
         <a:effectLst/>
         <a:uFillTx/>
-        <a:latin typeface="Arial"/>
-        <a:ea typeface="Arial"/>
-        <a:cs typeface="Arial"/>
-        <a:sym typeface="Arial"/>
+        <a:latin typeface="+mn-lt"/>
+        <a:ea typeface="+mn-ea"/>
+        <a:cs typeface="+mn-cs"/>
+        <a:sym typeface="Helvetica"/>
       </a:defRPr>
     </a:lvl8pPr>
-    <a:lvl9pPr marL="0" marR="0" indent="5184647" algn="l" defTabSz="648080" rtl="0" fontAlgn="auto" latinLnBrk="0" hangingPunct="0">
+    <a:lvl9pPr marL="0" marR="0" indent="0" algn="l" defTabSz="648080" rtl="0" fontAlgn="auto" latinLnBrk="0" hangingPunct="0">
       <a:lnSpc>
         <a:spcPct val="100000"/>
       </a:lnSpc>
@@ -310,10 +313,10 @@
         </a:solidFill>
         <a:effectLst/>
         <a:uFillTx/>
-        <a:latin typeface="Arial"/>
-        <a:ea typeface="Arial"/>
-        <a:cs typeface="Arial"/>
-        <a:sym typeface="Arial"/>
+        <a:latin typeface="+mn-lt"/>
+        <a:ea typeface="+mn-ea"/>
+        <a:cs typeface="+mn-cs"/>
+        <a:sym typeface="Helvetica"/>
       </a:defRPr>
     </a:lvl9pPr>
   </p:defaultTextStyle>
@@ -343,7 +346,7 @@
       </p:grpSpPr>
       <p:sp>
         <p:nvSpPr>
-          <p:cNvPr id="61" name="Shape 61"/>
+          <p:cNvPr id="73" name="Shape 73"/>
           <p:cNvSpPr/>
           <p:nvPr>
             <p:ph type="sldImg"/>
@@ -368,7 +371,7 @@
       </p:sp>
       <p:sp>
         <p:nvSpPr>
-          <p:cNvPr id="62" name="Shape 62"/>
+          <p:cNvPr id="74" name="Shape 74"/>
           <p:cNvSpPr/>
           <p:nvPr>
             <p:ph type="body" sz="quarter" idx="1"/>
@@ -472,177 +475,8 @@
 </file>
 
 <file path=ppt/slideLayouts/slideLayout1.xml><?xml version="1.0" encoding="utf-8"?>
-<p:sldLayout xmlns:a="http://schemas.openxmlformats.org/drawingml/2006/main" xmlns:r="http://schemas.openxmlformats.org/officeDocument/2006/relationships" xmlns:p="http://schemas.openxmlformats.org/presentationml/2006/main" xmlns:m="http://schemas.openxmlformats.org/officeDocument/2006/math" xmlns:a14="http://schemas.microsoft.com/office/drawing/2010/main" type="tx" showMasterSp="1" showMasterPhAnim="1">
+<p:sldLayout xmlns:a="http://schemas.openxmlformats.org/drawingml/2006/main" xmlns:r="http://schemas.openxmlformats.org/officeDocument/2006/relationships" xmlns:p="http://schemas.openxmlformats.org/presentationml/2006/main" xmlns:m="http://schemas.openxmlformats.org/officeDocument/2006/math" xmlns:a14="http://schemas.microsoft.com/office/drawing/2010/main" type="tx" showMasterSp="0" showMasterPhAnim="1">
   <p:cSld name="IWT_coverslide">
-    <p:spTree>
-      <p:nvGrpSpPr>
-        <p:cNvPr id="1" name=""/>
-        <p:cNvGrpSpPr/>
-        <p:nvPr/>
-      </p:nvGrpSpPr>
-      <p:grpSpPr>
-        <a:xfrm>
-          <a:off x="0" y="0"/>
-          <a:ext cx="0" cy="0"/>
-          <a:chOff x="0" y="0"/>
-          <a:chExt cx="0" cy="0"/>
-        </a:xfrm>
-      </p:grpSpPr>
-      <p:pic>
-        <p:nvPicPr>
-          <p:cNvPr id="16" name="Bild 1" descr="Bild 1"/>
-          <p:cNvPicPr>
-            <a:picLocks noChangeAspect="1"/>
-          </p:cNvPicPr>
-          <p:nvPr/>
-        </p:nvPicPr>
-        <p:blipFill>
-          <a:blip r:embed="rId2">
-            <a:extLst/>
-          </a:blip>
-          <a:stretch>
-            <a:fillRect/>
-          </a:stretch>
-        </p:blipFill>
-        <p:spPr>
-          <a:xfrm>
-            <a:off x="1" y="0"/>
-            <a:ext cx="12938126" cy="6706139"/>
-          </a:xfrm>
-          <a:prstGeom prst="rect">
-            <a:avLst/>
-          </a:prstGeom>
-          <a:ln w="12700">
-            <a:miter lim="400000"/>
-          </a:ln>
-        </p:spPr>
-      </p:pic>
-      <p:sp>
-        <p:nvSpPr>
-          <p:cNvPr id="17" name="Textfeld 271"/>
-          <p:cNvSpPr txBox="1"/>
-          <p:nvPr/>
-        </p:nvSpPr>
-        <p:spPr>
-          <a:xfrm>
-            <a:off x="10569532" y="1218837"/>
-            <a:ext cx="2037691" cy="754937"/>
-          </a:xfrm>
-          <a:prstGeom prst="rect">
-            <a:avLst/>
-          </a:prstGeom>
-          <a:ln w="12700">
-            <a:miter lim="400000"/>
-          </a:ln>
-          <a:extLst>
-            <a:ext uri="{C572A759-6A51-4108-AA02-DFA0A04FC94B}">
-              <ma14:wrappingTextBoxFlag xmlns:ma14="http://schemas.microsoft.com/office/mac/drawingml/2011/main" val="1"/>
-            </a:ext>
-          </a:extLst>
-        </p:spPr>
-        <p:txBody>
-          <a:bodyPr lIns="0" tIns="0" rIns="0" bIns="0">
-            <a:spAutoFit/>
-          </a:bodyPr>
-          <a:lstStyle/>
-          <a:p>
-            <a:pPr algn="r">
-              <a:defRPr spc="28" sz="1700"/>
-            </a:pPr>
-            <a:r>
-              <a:t>WISSEN</a:t>
-            </a:r>
-            <a:endParaRPr spc="39" sz="2400"/>
-          </a:p>
-          <a:p>
-            <a:pPr algn="r">
-              <a:defRPr spc="28" sz="1700"/>
-            </a:pPr>
-            <a:r>
-              <a:t>TECHNIK</a:t>
-            </a:r>
-            <a:endParaRPr spc="39" sz="2400"/>
-          </a:p>
-          <a:p>
-            <a:pPr algn="r">
-              <a:defRPr spc="28" sz="1700"/>
-            </a:pPr>
-            <a:r>
-              <a:t>LEIDENSCHAFT</a:t>
-            </a:r>
-          </a:p>
-        </p:txBody>
-      </p:sp>
-      <p:sp>
-        <p:nvSpPr>
-          <p:cNvPr id="18" name="Klicken und eine Überschrift hinzufügen"/>
-          <p:cNvSpPr txBox="1"/>
-          <p:nvPr>
-            <p:ph type="title" hasCustomPrompt="1"/>
-          </p:nvPr>
-        </p:nvSpPr>
-        <p:spPr>
-          <a:xfrm>
-            <a:off x="879471" y="1398587"/>
-            <a:ext cx="8658002" cy="2426401"/>
-          </a:xfrm>
-          <a:prstGeom prst="rect">
-            <a:avLst/>
-          </a:prstGeom>
-        </p:spPr>
-        <p:txBody>
-          <a:bodyPr anchor="b"/>
-          <a:lstStyle>
-            <a:lvl1pPr>
-              <a:defRPr b="1" sz="4500">
-                <a:solidFill>
-                  <a:srgbClr val="F70146"/>
-                </a:solidFill>
-              </a:defRPr>
-            </a:lvl1pPr>
-          </a:lstStyle>
-          <a:p>
-            <a:pPr/>
-            <a:r>
-              <a:t>Klicken und eine Überschrift hinzufügen</a:t>
-            </a:r>
-          </a:p>
-        </p:txBody>
-      </p:sp>
-      <p:sp>
-        <p:nvSpPr>
-          <p:cNvPr id="19" name="Foliennummer"/>
-          <p:cNvSpPr txBox="1"/>
-          <p:nvPr>
-            <p:ph type="sldNum" sz="quarter" idx="2"/>
-          </p:nvPr>
-        </p:nvSpPr>
-        <p:spPr>
-          <a:prstGeom prst="rect">
-            <a:avLst/>
-          </a:prstGeom>
-        </p:spPr>
-        <p:txBody>
-          <a:bodyPr/>
-          <a:lstStyle/>
-          <a:p>
-            <a:pPr/>
-            <a:fld id="{86CB4B4D-7CA3-9044-876B-883B54F8677D}" type="slidenum"/>
-          </a:p>
-        </p:txBody>
-      </p:sp>
-    </p:spTree>
-  </p:cSld>
-  <p:clrMapOvr>
-    <a:masterClrMapping/>
-  </p:clrMapOvr>
-  <p:transition xmlns:p14="http://schemas.microsoft.com/office/powerpoint/2010/main" spd="med" advClick="1"/>
-</p:sldLayout>
-</file>
-
-<file path=ppt/slideLayouts/slideLayout2.xml><?xml version="1.0" encoding="utf-8"?>
-<p:sldLayout xmlns:a="http://schemas.openxmlformats.org/drawingml/2006/main" xmlns:r="http://schemas.openxmlformats.org/officeDocument/2006/relationships" xmlns:p="http://schemas.openxmlformats.org/presentationml/2006/main" xmlns:m="http://schemas.openxmlformats.org/officeDocument/2006/math" xmlns:a14="http://schemas.microsoft.com/office/drawing/2010/main" type="tx" showMasterSp="1" showMasterPhAnim="1">
-  <p:cSld name="IWT_title_1line">
     <p:spTree>
       <p:nvGrpSpPr>
         <p:cNvPr id="1" name=""/>
@@ -659,20 +493,707 @@
       </p:grpSpPr>
       <p:sp>
         <p:nvSpPr>
-          <p:cNvPr id="26" name="Titeltext"/>
+          <p:cNvPr id="17" name="Rechteck 7"/>
+          <p:cNvSpPr/>
+          <p:nvPr/>
+        </p:nvSpPr>
+        <p:spPr>
+          <a:xfrm>
+            <a:off x="0" y="6707199"/>
+            <a:ext cx="12938125" cy="614118"/>
+          </a:xfrm>
+          <a:prstGeom prst="rect">
+            <a:avLst/>
+          </a:prstGeom>
+          <a:solidFill>
+            <a:srgbClr val="D9D9D9"/>
+          </a:solidFill>
+          <a:ln w="12700">
+            <a:miter lim="400000"/>
+          </a:ln>
+        </p:spPr>
+        <p:txBody>
+          <a:bodyPr lIns="45718" tIns="45718" rIns="45718" bIns="45718" anchor="ctr"/>
+          <a:lstStyle/>
+          <a:p>
+            <a:pPr algn="ctr">
+              <a:defRPr>
+                <a:solidFill>
+                  <a:srgbClr val="FFFFFF"/>
+                </a:solidFill>
+                <a:latin typeface="Arial"/>
+                <a:ea typeface="Arial"/>
+                <a:cs typeface="Arial"/>
+                <a:sym typeface="Arial"/>
+              </a:defRPr>
+            </a:pPr>
+          </a:p>
+        </p:txBody>
+      </p:sp>
+      <p:sp>
+        <p:nvSpPr>
+          <p:cNvPr id="18" name="Gerade Verbindung 17"/>
+          <p:cNvSpPr/>
+          <p:nvPr/>
+        </p:nvSpPr>
+        <p:spPr>
+          <a:xfrm>
+            <a:off x="880586" y="715716"/>
+            <a:ext cx="11868858" cy="1"/>
+          </a:xfrm>
+          <a:prstGeom prst="line">
+            <a:avLst/>
+          </a:prstGeom>
+          <a:ln w="6350">
+            <a:solidFill>
+              <a:srgbClr val="000000"/>
+            </a:solidFill>
+          </a:ln>
+        </p:spPr>
+        <p:txBody>
+          <a:bodyPr lIns="45718" tIns="45718" rIns="45718" bIns="45718"/>
+          <a:lstStyle/>
+          <a:p>
+            <a:pPr/>
+          </a:p>
+        </p:txBody>
+      </p:sp>
+      <p:pic>
+        <p:nvPicPr>
+          <p:cNvPr id="19" name="Bild 21" descr="Bild 21"/>
+          <p:cNvPicPr>
+            <a:picLocks noChangeAspect="1"/>
+          </p:cNvPicPr>
+          <p:nvPr/>
+        </p:nvPicPr>
+        <p:blipFill>
+          <a:blip r:embed="rId2">
+            <a:extLst/>
+          </a:blip>
+          <a:stretch>
+            <a:fillRect/>
+          </a:stretch>
+        </p:blipFill>
+        <p:spPr>
+          <a:xfrm>
+            <a:off x="11523016" y="150773"/>
+            <a:ext cx="1226428" cy="453804"/>
+          </a:xfrm>
+          <a:prstGeom prst="rect">
+            <a:avLst/>
+          </a:prstGeom>
+          <a:ln w="12700">
+            <a:miter lim="400000"/>
+          </a:ln>
+        </p:spPr>
+      </p:pic>
+      <p:sp>
+        <p:nvSpPr>
+          <p:cNvPr id="20" name="Textfeld 14"/>
+          <p:cNvSpPr txBox="1"/>
+          <p:nvPr/>
+        </p:nvSpPr>
+        <p:spPr>
+          <a:xfrm>
+            <a:off x="880588" y="6827791"/>
+            <a:ext cx="7675317" cy="400585"/>
+          </a:xfrm>
+          <a:prstGeom prst="rect">
+            <a:avLst/>
+          </a:prstGeom>
+          <a:ln w="12700">
+            <a:miter lim="400000"/>
+          </a:ln>
+          <a:extLst>
+            <a:ext uri="{C572A759-6A51-4108-AA02-DFA0A04FC94B}">
+              <ma14:wrappingTextBoxFlag xmlns:ma14="http://schemas.microsoft.com/office/mac/drawingml/2011/main" val="1"/>
+            </a:ext>
+          </a:extLst>
+        </p:spPr>
+        <p:txBody>
+          <a:bodyPr lIns="0" tIns="0" rIns="0" bIns="0">
+            <a:spAutoFit/>
+          </a:bodyPr>
+          <a:lstStyle/>
+          <a:p>
+            <a:pPr>
+              <a:defRPr sz="1400">
+                <a:latin typeface="Arial"/>
+                <a:ea typeface="Arial"/>
+                <a:cs typeface="Arial"/>
+                <a:sym typeface="Arial"/>
+              </a:defRPr>
+            </a:pPr>
+            <a:r>
+              <a:t>Kontakt: </a:t>
+            </a:r>
+            <a:r>
+              <a:rPr u="sng">
+                <a:solidFill>
+                  <a:srgbClr val="0000FF"/>
+                </a:solidFill>
+                <a:uFill>
+                  <a:solidFill>
+                    <a:srgbClr val="0000FF"/>
+                  </a:solidFill>
+                </a:uFill>
+                <a:hlinkClick r:id="rId3" invalidUrl="" action="" tgtFrame="" tooltip="" history="1" highlightClick="0" endSnd="0"/>
+              </a:rPr>
+              <a:t>....@tugraz.at</a:t>
+            </a:r>
+            <a:r>
+              <a:t>, </a:t>
+            </a:r>
+            <a:r>
+              <a:rPr u="sng">
+                <a:solidFill>
+                  <a:srgbClr val="0000FF"/>
+                </a:solidFill>
+                <a:uFill>
+                  <a:solidFill>
+                    <a:srgbClr val="0000FF"/>
+                  </a:solidFill>
+                </a:uFill>
+                <a:hlinkClick r:id="rId4" invalidUrl="" action="" tgtFrame="" tooltip="" history="1" highlightClick="0" endSnd="0"/>
+              </a:rPr>
+              <a:t>www.iwt.tugraz.at</a:t>
+            </a:r>
+            <a:endParaRPr u="sng">
+              <a:solidFill>
+                <a:srgbClr val="0070C0"/>
+              </a:solidFill>
+            </a:endParaRPr>
+          </a:p>
+          <a:p>
+            <a:pPr>
+              <a:defRPr sz="1400">
+                <a:latin typeface="Arial"/>
+                <a:ea typeface="Arial"/>
+                <a:cs typeface="Arial"/>
+                <a:sym typeface="Arial"/>
+              </a:defRPr>
+            </a:pPr>
+            <a:r>
+              <a:t>Titel der Veranstaltung, Ort &amp; Datum</a:t>
+            </a:r>
+          </a:p>
+        </p:txBody>
+      </p:sp>
+      <p:sp>
+        <p:nvSpPr>
+          <p:cNvPr id="21" name="Rechteck 19"/>
+          <p:cNvSpPr/>
+          <p:nvPr/>
+        </p:nvSpPr>
+        <p:spPr>
+          <a:xfrm>
+            <a:off x="1" y="715716"/>
+            <a:ext cx="610968" cy="614118"/>
+          </a:xfrm>
+          <a:prstGeom prst="rect">
+            <a:avLst/>
+          </a:prstGeom>
+          <a:solidFill>
+            <a:srgbClr val="F70146"/>
+          </a:solidFill>
+          <a:ln w="12700">
+            <a:miter lim="400000"/>
+          </a:ln>
+        </p:spPr>
+        <p:txBody>
+          <a:bodyPr lIns="45718" tIns="45718" rIns="45718" bIns="45718" anchor="ctr"/>
+          <a:lstStyle/>
+          <a:p>
+            <a:pPr algn="ctr">
+              <a:defRPr>
+                <a:solidFill>
+                  <a:srgbClr val="FFFFFF"/>
+                </a:solidFill>
+                <a:latin typeface="Arial"/>
+                <a:ea typeface="Arial"/>
+                <a:cs typeface="Arial"/>
+                <a:sym typeface="Arial"/>
+              </a:defRPr>
+            </a:pPr>
+          </a:p>
+        </p:txBody>
+      </p:sp>
+      <p:pic>
+        <p:nvPicPr>
+          <p:cNvPr id="22" name="Bild 1" descr="Bild 1"/>
+          <p:cNvPicPr>
+            <a:picLocks noChangeAspect="1"/>
+          </p:cNvPicPr>
+          <p:nvPr/>
+        </p:nvPicPr>
+        <p:blipFill>
+          <a:blip r:embed="rId5">
+            <a:extLst/>
+          </a:blip>
+          <a:stretch>
+            <a:fillRect/>
+          </a:stretch>
+        </p:blipFill>
+        <p:spPr>
+          <a:xfrm>
+            <a:off x="1" y="0"/>
+            <a:ext cx="12938126" cy="6706139"/>
+          </a:xfrm>
+          <a:prstGeom prst="rect">
+            <a:avLst/>
+          </a:prstGeom>
+          <a:ln w="12700">
+            <a:miter lim="400000"/>
+          </a:ln>
+          <a:effectLst>
+            <a:outerShdw sx="100000" sy="100000" kx="0" ky="0" algn="b" rotWithShape="0" blurRad="254000" dist="127000" dir="16200000">
+              <a:srgbClr val="000000">
+                <a:alpha val="70000"/>
+              </a:srgbClr>
+            </a:outerShdw>
+          </a:effectLst>
+        </p:spPr>
+      </p:pic>
+      <p:sp>
+        <p:nvSpPr>
+          <p:cNvPr id="23" name="Textfeld 271"/>
+          <p:cNvSpPr txBox="1"/>
+          <p:nvPr/>
+        </p:nvSpPr>
+        <p:spPr>
+          <a:xfrm>
+            <a:off x="10569532" y="1218837"/>
+            <a:ext cx="2037691" cy="754937"/>
+          </a:xfrm>
+          <a:prstGeom prst="rect">
+            <a:avLst/>
+          </a:prstGeom>
+          <a:ln w="12700">
+            <a:miter lim="400000"/>
+          </a:ln>
+          <a:extLst>
+            <a:ext uri="{C572A759-6A51-4108-AA02-DFA0A04FC94B}">
+              <ma14:wrappingTextBoxFlag xmlns:ma14="http://schemas.microsoft.com/office/mac/drawingml/2011/main" val="1"/>
+            </a:ext>
+          </a:extLst>
+        </p:spPr>
+        <p:txBody>
+          <a:bodyPr lIns="0" tIns="0" rIns="0" bIns="0">
+            <a:spAutoFit/>
+          </a:bodyPr>
+          <a:lstStyle/>
+          <a:p>
+            <a:pPr algn="r">
+              <a:defRPr spc="28" sz="1700">
+                <a:latin typeface="Arial"/>
+                <a:ea typeface="Arial"/>
+                <a:cs typeface="Arial"/>
+                <a:sym typeface="Arial"/>
+              </a:defRPr>
+            </a:pPr>
+            <a:r>
+              <a:t>WISSEN</a:t>
+            </a:r>
+            <a:endParaRPr spc="39" sz="2400"/>
+          </a:p>
+          <a:p>
+            <a:pPr algn="r">
+              <a:defRPr spc="28" sz="1700">
+                <a:latin typeface="Arial"/>
+                <a:ea typeface="Arial"/>
+                <a:cs typeface="Arial"/>
+                <a:sym typeface="Arial"/>
+              </a:defRPr>
+            </a:pPr>
+            <a:r>
+              <a:t>TECHNIK</a:t>
+            </a:r>
+            <a:endParaRPr spc="39" sz="2400"/>
+          </a:p>
+          <a:p>
+            <a:pPr algn="r">
+              <a:defRPr spc="28" sz="1700">
+                <a:latin typeface="Arial"/>
+                <a:ea typeface="Arial"/>
+                <a:cs typeface="Arial"/>
+                <a:sym typeface="Arial"/>
+              </a:defRPr>
+            </a:pPr>
+            <a:r>
+              <a:t>LEIDENSCHAFT</a:t>
+            </a:r>
+          </a:p>
+        </p:txBody>
+      </p:sp>
+      <p:sp>
+        <p:nvSpPr>
+          <p:cNvPr id="24" name="Klicken und eine Überschrift hinzufügen"/>
+          <p:cNvSpPr txBox="1"/>
+          <p:nvPr>
+            <p:ph type="title" hasCustomPrompt="1"/>
+          </p:nvPr>
+        </p:nvSpPr>
+        <p:spPr>
+          <a:xfrm>
+            <a:off x="879471" y="1398587"/>
+            <a:ext cx="8658002" cy="2426401"/>
+          </a:xfrm>
+          <a:prstGeom prst="rect">
+            <a:avLst/>
+          </a:prstGeom>
+        </p:spPr>
+        <p:txBody>
+          <a:bodyPr anchor="b"/>
+          <a:lstStyle>
+            <a:lvl1pPr>
+              <a:defRPr b="1" sz="4500">
+                <a:solidFill>
+                  <a:srgbClr val="F70146"/>
+                </a:solidFill>
+              </a:defRPr>
+            </a:lvl1pPr>
+          </a:lstStyle>
+          <a:p>
+            <a:pPr/>
+            <a:r>
+              <a:t>Klicken und eine Überschrift hinzufügen</a:t>
+            </a:r>
+          </a:p>
+        </p:txBody>
+      </p:sp>
+      <p:sp>
+        <p:nvSpPr>
+          <p:cNvPr id="25" name="Foliennummer"/>
+          <p:cNvSpPr txBox="1"/>
+          <p:nvPr>
+            <p:ph type="sldNum" sz="quarter" idx="2"/>
+          </p:nvPr>
+        </p:nvSpPr>
+        <p:spPr>
+          <a:prstGeom prst="rect">
+            <a:avLst/>
+          </a:prstGeom>
+        </p:spPr>
+        <p:txBody>
+          <a:bodyPr/>
+          <a:lstStyle/>
+          <a:p>
+            <a:pPr/>
+            <a:fld id="{86CB4B4D-7CA3-9044-876B-883B54F8677D}" type="slidenum"/>
+          </a:p>
+        </p:txBody>
+      </p:sp>
+    </p:spTree>
+  </p:cSld>
+  <p:clrMapOvr>
+    <a:masterClrMapping/>
+  </p:clrMapOvr>
+  <p:transition xmlns:p14="http://schemas.microsoft.com/office/powerpoint/2010/main" spd="med" advClick="1"/>
+</p:sldLayout>
+</file>
+
+<file path=ppt/slideLayouts/slideLayout2.xml><?xml version="1.0" encoding="utf-8"?>
+<p:sldLayout xmlns:a="http://schemas.openxmlformats.org/drawingml/2006/main" xmlns:r="http://schemas.openxmlformats.org/officeDocument/2006/relationships" xmlns:p="http://schemas.openxmlformats.org/presentationml/2006/main" xmlns:m="http://schemas.openxmlformats.org/officeDocument/2006/math" xmlns:a14="http://schemas.microsoft.com/office/drawing/2010/main" type="tx" showMasterSp="0" showMasterPhAnim="1">
+  <p:cSld name="IWT_title_1line">
+    <p:bg>
+      <p:bgPr>
+        <a:gradFill flip="none" rotWithShape="1">
+          <a:gsLst>
+            <a:gs pos="0">
+              <a:srgbClr val="FDFDFD"/>
+            </a:gs>
+            <a:gs pos="100000">
+              <a:srgbClr val="E0EEFF"/>
+            </a:gs>
+          </a:gsLst>
+          <a:lin ang="16200000" scaled="0"/>
+        </a:gradFill>
+      </p:bgPr>
+    </p:bg>
+    <p:spTree>
+      <p:nvGrpSpPr>
+        <p:cNvPr id="1" name=""/>
+        <p:cNvGrpSpPr/>
+        <p:nvPr/>
+      </p:nvGrpSpPr>
+      <p:grpSpPr>
+        <a:xfrm>
+          <a:off x="0" y="0"/>
+          <a:ext cx="0" cy="0"/>
+          <a:chOff x="0" y="0"/>
+          <a:chExt cx="0" cy="0"/>
+        </a:xfrm>
+      </p:grpSpPr>
+      <p:sp>
+        <p:nvSpPr>
+          <p:cNvPr id="32" name="Rechteck 7"/>
+          <p:cNvSpPr/>
+          <p:nvPr/>
+        </p:nvSpPr>
+        <p:spPr>
+          <a:xfrm>
+            <a:off x="0" y="6707199"/>
+            <a:ext cx="12938125" cy="614118"/>
+          </a:xfrm>
+          <a:prstGeom prst="rect">
+            <a:avLst/>
+          </a:prstGeom>
+          <a:gradFill>
+            <a:gsLst>
+              <a:gs pos="0">
+                <a:srgbClr val="7DA0D3"/>
+              </a:gs>
+              <a:gs pos="100000">
+                <a:schemeClr val="accent1">
+                  <a:hueOff val="456700"/>
+                  <a:satOff val="47967"/>
+                  <a:lumOff val="43351"/>
+                </a:schemeClr>
+              </a:gs>
+            </a:gsLst>
+            <a:lin ang="16200000"/>
+          </a:gradFill>
+          <a:ln w="12700">
+            <a:miter lim="400000"/>
+          </a:ln>
+        </p:spPr>
+        <p:txBody>
+          <a:bodyPr lIns="45718" tIns="45718" rIns="45718" bIns="45718" anchor="ctr"/>
+          <a:lstStyle/>
+          <a:p>
+            <a:pPr algn="ctr">
+              <a:defRPr>
+                <a:solidFill>
+                  <a:srgbClr val="FFFFFF"/>
+                </a:solidFill>
+                <a:latin typeface="Arial"/>
+                <a:ea typeface="Arial"/>
+                <a:cs typeface="Arial"/>
+                <a:sym typeface="Arial"/>
+              </a:defRPr>
+            </a:pPr>
+          </a:p>
+        </p:txBody>
+      </p:sp>
+      <p:sp>
+        <p:nvSpPr>
+          <p:cNvPr id="33" name="Gerade Verbindung 17"/>
+          <p:cNvSpPr/>
+          <p:nvPr/>
+        </p:nvSpPr>
+        <p:spPr>
+          <a:xfrm>
+            <a:off x="880586" y="715716"/>
+            <a:ext cx="11868858" cy="1"/>
+          </a:xfrm>
+          <a:prstGeom prst="line">
+            <a:avLst/>
+          </a:prstGeom>
+          <a:ln w="6350">
+            <a:solidFill>
+              <a:srgbClr val="000000"/>
+            </a:solidFill>
+          </a:ln>
+        </p:spPr>
+        <p:txBody>
+          <a:bodyPr lIns="45718" tIns="45718" rIns="45718" bIns="45718"/>
+          <a:lstStyle/>
+          <a:p>
+            <a:pPr/>
+          </a:p>
+        </p:txBody>
+      </p:sp>
+      <p:pic>
+        <p:nvPicPr>
+          <p:cNvPr id="34" name="Bild 21" descr="Bild 21"/>
+          <p:cNvPicPr>
+            <a:picLocks noChangeAspect="1"/>
+          </p:cNvPicPr>
+          <p:nvPr/>
+        </p:nvPicPr>
+        <p:blipFill>
+          <a:blip r:embed="rId2">
+            <a:extLst/>
+          </a:blip>
+          <a:stretch>
+            <a:fillRect/>
+          </a:stretch>
+        </p:blipFill>
+        <p:spPr>
+          <a:xfrm>
+            <a:off x="11523016" y="150773"/>
+            <a:ext cx="1226428" cy="453804"/>
+          </a:xfrm>
+          <a:prstGeom prst="rect">
+            <a:avLst/>
+          </a:prstGeom>
+          <a:ln w="12700">
+            <a:miter lim="400000"/>
+          </a:ln>
+          <a:effectLst>
+            <a:reflection blurRad="0" stA="50000" stPos="0" endA="0" endPos="40000" dist="0" dir="5400000" fadeDir="5400000" sx="100000" sy="-100000" kx="0" ky="0" algn="bl" rotWithShape="0"/>
+          </a:effectLst>
+        </p:spPr>
+      </p:pic>
+      <p:sp>
+        <p:nvSpPr>
+          <p:cNvPr id="35" name="Textfeld 14"/>
+          <p:cNvSpPr txBox="1"/>
+          <p:nvPr/>
+        </p:nvSpPr>
+        <p:spPr>
+          <a:xfrm>
+            <a:off x="880588" y="6827791"/>
+            <a:ext cx="7675317" cy="400585"/>
+          </a:xfrm>
+          <a:prstGeom prst="rect">
+            <a:avLst/>
+          </a:prstGeom>
+          <a:ln w="12700">
+            <a:miter lim="400000"/>
+          </a:ln>
+          <a:extLst>
+            <a:ext uri="{C572A759-6A51-4108-AA02-DFA0A04FC94B}">
+              <ma14:wrappingTextBoxFlag xmlns:ma14="http://schemas.microsoft.com/office/mac/drawingml/2011/main" val="1"/>
+            </a:ext>
+          </a:extLst>
+        </p:spPr>
+        <p:txBody>
+          <a:bodyPr lIns="0" tIns="0" rIns="0" bIns="0">
+            <a:spAutoFit/>
+          </a:bodyPr>
+          <a:lstStyle/>
+          <a:p>
+            <a:pPr>
+              <a:defRPr sz="1400">
+                <a:latin typeface="Arial"/>
+                <a:ea typeface="Arial"/>
+                <a:cs typeface="Arial"/>
+                <a:sym typeface="Arial"/>
+              </a:defRPr>
+            </a:pPr>
+            <a:r>
+              <a:t>Kontakt: </a:t>
+            </a:r>
+            <a:r>
+              <a:rPr u="sng">
+                <a:solidFill>
+                  <a:srgbClr val="0000FF"/>
+                </a:solidFill>
+                <a:uFill>
+                  <a:solidFill>
+                    <a:srgbClr val="0000FF"/>
+                  </a:solidFill>
+                </a:uFill>
+                <a:hlinkClick r:id="rId3" invalidUrl="" action="" tgtFrame="" tooltip="" history="1" highlightClick="0" endSnd="0"/>
+              </a:rPr>
+              <a:t>....@tugraz.at</a:t>
+            </a:r>
+            <a:r>
+              <a:t>, </a:t>
+            </a:r>
+            <a:r>
+              <a:rPr u="sng">
+                <a:solidFill>
+                  <a:srgbClr val="0000FF"/>
+                </a:solidFill>
+                <a:uFill>
+                  <a:solidFill>
+                    <a:srgbClr val="0000FF"/>
+                  </a:solidFill>
+                </a:uFill>
+                <a:hlinkClick r:id="rId4" invalidUrl="" action="" tgtFrame="" tooltip="" history="1" highlightClick="0" endSnd="0"/>
+              </a:rPr>
+              <a:t>www.iwt.tugraz.at</a:t>
+            </a:r>
+            <a:endParaRPr u="sng">
+              <a:solidFill>
+                <a:srgbClr val="0070C0"/>
+              </a:solidFill>
+            </a:endParaRPr>
+          </a:p>
+          <a:p>
+            <a:pPr>
+              <a:defRPr sz="1400">
+                <a:latin typeface="Arial"/>
+                <a:ea typeface="Arial"/>
+                <a:cs typeface="Arial"/>
+                <a:sym typeface="Arial"/>
+              </a:defRPr>
+            </a:pPr>
+            <a:r>
+              <a:t>Titel der Veranstaltung, Ort &amp; Datum</a:t>
+            </a:r>
+          </a:p>
+        </p:txBody>
+      </p:sp>
+      <p:sp>
+        <p:nvSpPr>
+          <p:cNvPr id="36" name="Rechteck 19"/>
+          <p:cNvSpPr/>
+          <p:nvPr/>
+        </p:nvSpPr>
+        <p:spPr>
+          <a:xfrm>
+            <a:off x="1" y="715716"/>
+            <a:ext cx="610968" cy="614118"/>
+          </a:xfrm>
+          <a:prstGeom prst="rect">
+            <a:avLst/>
+          </a:prstGeom>
+          <a:solidFill>
+            <a:srgbClr val="F70146"/>
+          </a:solidFill>
+          <a:ln w="12700">
+            <a:miter lim="400000"/>
+          </a:ln>
+        </p:spPr>
+        <p:txBody>
+          <a:bodyPr lIns="45718" tIns="45718" rIns="45718" bIns="45718" anchor="ctr"/>
+          <a:lstStyle/>
+          <a:p>
+            <a:pPr algn="ctr">
+              <a:defRPr>
+                <a:solidFill>
+                  <a:srgbClr val="FFA700"/>
+                </a:solidFill>
+                <a:latin typeface="Arial"/>
+                <a:ea typeface="Arial"/>
+                <a:cs typeface="Arial"/>
+                <a:sym typeface="Arial"/>
+              </a:defRPr>
+            </a:pPr>
+          </a:p>
+        </p:txBody>
+      </p:sp>
+      <p:sp>
+        <p:nvSpPr>
+          <p:cNvPr id="37" name="Titeltext"/>
           <p:cNvSpPr txBox="1"/>
           <p:nvPr>
             <p:ph type="title"/>
           </p:nvPr>
         </p:nvSpPr>
         <p:spPr>
+          <a:xfrm>
+            <a:off x="880588" y="884237"/>
+            <a:ext cx="5034735" cy="614118"/>
+          </a:xfrm>
           <a:prstGeom prst="rect">
             <a:avLst/>
           </a:prstGeom>
         </p:spPr>
         <p:txBody>
           <a:bodyPr/>
-          <a:lstStyle/>
+          <a:lstStyle>
+            <a:lvl1pPr>
+              <a:defRPr>
+                <a:solidFill>
+                  <a:srgbClr val="080203"/>
+                </a:solidFill>
+              </a:defRPr>
+            </a:lvl1pPr>
+          </a:lstStyle>
           <a:p>
             <a:pPr/>
             <a:r>
@@ -683,7 +1204,7 @@
       </p:sp>
       <p:sp>
         <p:nvSpPr>
-          <p:cNvPr id="27" name="Textebene 1…"/>
+          <p:cNvPr id="38" name="Textebene 1…"/>
           <p:cNvSpPr txBox="1"/>
           <p:nvPr>
             <p:ph type="body" sz="quarter" idx="1"/>
@@ -731,7 +1252,119 @@
       </p:sp>
       <p:sp>
         <p:nvSpPr>
-          <p:cNvPr id="28" name="Foliennummer"/>
+          <p:cNvPr id="39" name="Hockey"/>
+          <p:cNvSpPr/>
+          <p:nvPr/>
+        </p:nvSpPr>
+        <p:spPr>
+          <a:xfrm>
+            <a:off x="11784622" y="5265199"/>
+            <a:ext cx="1066406" cy="1983968"/>
+          </a:xfrm>
+          <a:custGeom>
+            <a:avLst/>
+            <a:gdLst/>
+            <a:ahLst/>
+            <a:cxnLst>
+              <a:cxn ang="0">
+                <a:pos x="wd2" y="hd2"/>
+              </a:cxn>
+              <a:cxn ang="5400000">
+                <a:pos x="wd2" y="hd2"/>
+              </a:cxn>
+              <a:cxn ang="10800000">
+                <a:pos x="wd2" y="hd2"/>
+              </a:cxn>
+              <a:cxn ang="16200000">
+                <a:pos x="wd2" y="hd2"/>
+              </a:cxn>
+            </a:cxnLst>
+            <a:rect l="0" t="0" r="r" b="b"/>
+            <a:pathLst>
+              <a:path w="21137" h="21405" fill="norm" stroke="1" extrusionOk="0">
+                <a:moveTo>
+                  <a:pt x="20360" y="4"/>
+                </a:moveTo>
+                <a:cubicBezTo>
+                  <a:pt x="20162" y="-10"/>
+                  <a:pt x="19920" y="15"/>
+                  <a:pt x="19622" y="104"/>
+                </a:cubicBezTo>
+                <a:lnTo>
+                  <a:pt x="8335" y="17757"/>
+                </a:lnTo>
+                <a:cubicBezTo>
+                  <a:pt x="8335" y="17757"/>
+                  <a:pt x="7581" y="18867"/>
+                  <a:pt x="4624" y="19356"/>
+                </a:cubicBezTo>
+                <a:lnTo>
+                  <a:pt x="627" y="20043"/>
+                </a:lnTo>
+                <a:cubicBezTo>
+                  <a:pt x="627" y="20043"/>
+                  <a:pt x="-463" y="20176"/>
+                  <a:pt x="230" y="20754"/>
+                </a:cubicBezTo>
+                <a:cubicBezTo>
+                  <a:pt x="230" y="20754"/>
+                  <a:pt x="666" y="21176"/>
+                  <a:pt x="1088" y="21302"/>
+                </a:cubicBezTo>
+                <a:cubicBezTo>
+                  <a:pt x="1088" y="21302"/>
+                  <a:pt x="1726" y="21590"/>
+                  <a:pt x="3453" y="21205"/>
+                </a:cubicBezTo>
+                <a:lnTo>
+                  <a:pt x="6406" y="20473"/>
+                </a:lnTo>
+                <a:cubicBezTo>
+                  <a:pt x="6406" y="20473"/>
+                  <a:pt x="8092" y="20229"/>
+                  <a:pt x="8903" y="19346"/>
+                </a:cubicBezTo>
+                <a:lnTo>
+                  <a:pt x="21137" y="432"/>
+                </a:lnTo>
+                <a:cubicBezTo>
+                  <a:pt x="21137" y="432"/>
+                  <a:pt x="20953" y="46"/>
+                  <a:pt x="20360" y="4"/>
+                </a:cubicBezTo>
+                <a:close/>
+              </a:path>
+            </a:pathLst>
+          </a:custGeom>
+          <a:solidFill>
+            <a:srgbClr val="FFEBE7"/>
+          </a:solidFill>
+          <a:ln w="25400">
+            <a:solidFill>
+              <a:srgbClr val="E2324C"/>
+            </a:solidFill>
+          </a:ln>
+          <a:effectLst>
+            <a:reflection blurRad="0" stA="50000" stPos="0" endA="0" endPos="40000" dist="0" dir="5400000" fadeDir="5400000" sx="100000" sy="-100000" kx="0" ky="0" algn="bl" rotWithShape="0"/>
+          </a:effectLst>
+        </p:spPr>
+        <p:txBody>
+          <a:bodyPr lIns="45718" tIns="45718" rIns="45718" bIns="45718" anchor="ctr"/>
+          <a:lstStyle/>
+          <a:p>
+            <a:pPr>
+              <a:defRPr>
+                <a:solidFill>
+                  <a:srgbClr val="B5160F"/>
+                </a:solidFill>
+              </a:defRPr>
+            </a:pPr>
+          </a:p>
+        </p:txBody>
+      </p:sp>
+      <p:sp>
+        <p:nvSpPr>
+          <p:cNvPr id="40" name="Foliennummer"/>
           <p:cNvSpPr txBox="1"/>
           <p:nvPr>
             <p:ph type="sldNum" sz="quarter" idx="2"/>
@@ -779,7 +1412,7 @@
       </p:grpSpPr>
       <p:sp>
         <p:nvSpPr>
-          <p:cNvPr id="35" name="Textebene 1…"/>
+          <p:cNvPr id="47" name="Textebene 1…"/>
           <p:cNvSpPr txBox="1"/>
           <p:nvPr>
             <p:ph type="body" sz="quarter" idx="1"/>
@@ -827,17 +1460,13 @@
       </p:sp>
       <p:sp>
         <p:nvSpPr>
-          <p:cNvPr id="36" name="Titeltext"/>
+          <p:cNvPr id="48" name="Titeltext"/>
           <p:cNvSpPr txBox="1"/>
           <p:nvPr>
             <p:ph type="title"/>
           </p:nvPr>
         </p:nvSpPr>
         <p:spPr>
-          <a:xfrm>
-            <a:off x="880588" y="884237"/>
-            <a:ext cx="11876400" cy="1220402"/>
-          </a:xfrm>
           <a:prstGeom prst="rect">
             <a:avLst/>
           </a:prstGeom>
@@ -855,7 +1484,7 @@
       </p:sp>
       <p:sp>
         <p:nvSpPr>
-          <p:cNvPr id="37" name="Foliennummer"/>
+          <p:cNvPr id="49" name="Foliennummer"/>
           <p:cNvSpPr txBox="1"/>
           <p:nvPr>
             <p:ph type="sldNum" sz="quarter" idx="2"/>
@@ -903,13 +1532,17 @@
       </p:grpSpPr>
       <p:sp>
         <p:nvSpPr>
-          <p:cNvPr id="44" name="Titeltext"/>
+          <p:cNvPr id="56" name="Titeltext"/>
           <p:cNvSpPr txBox="1"/>
           <p:nvPr>
             <p:ph type="title"/>
           </p:nvPr>
         </p:nvSpPr>
         <p:spPr>
+          <a:xfrm>
+            <a:off x="880588" y="884237"/>
+            <a:ext cx="11876400" cy="614118"/>
+          </a:xfrm>
           <a:prstGeom prst="rect">
             <a:avLst/>
           </a:prstGeom>
@@ -927,7 +1560,7 @@
       </p:sp>
       <p:sp>
         <p:nvSpPr>
-          <p:cNvPr id="45" name="Textebene 1…"/>
+          <p:cNvPr id="57" name="Textebene 1…"/>
           <p:cNvSpPr txBox="1"/>
           <p:nvPr>
             <p:ph type="body" sz="quarter" idx="1"/>
@@ -975,7 +1608,7 @@
       </p:sp>
       <p:sp>
         <p:nvSpPr>
-          <p:cNvPr id="46" name="Foliennummer"/>
+          <p:cNvPr id="58" name="Foliennummer"/>
           <p:cNvSpPr txBox="1"/>
           <p:nvPr>
             <p:ph type="sldNum" sz="quarter" idx="2"/>
@@ -1023,17 +1656,13 @@
       </p:grpSpPr>
       <p:sp>
         <p:nvSpPr>
-          <p:cNvPr id="53" name="Titeltext"/>
+          <p:cNvPr id="65" name="Titeltext"/>
           <p:cNvSpPr txBox="1"/>
           <p:nvPr>
             <p:ph type="title"/>
           </p:nvPr>
         </p:nvSpPr>
         <p:spPr>
-          <a:xfrm>
-            <a:off x="880588" y="884237"/>
-            <a:ext cx="11876400" cy="1220402"/>
-          </a:xfrm>
           <a:prstGeom prst="rect">
             <a:avLst/>
           </a:prstGeom>
@@ -1051,7 +1680,7 @@
       </p:sp>
       <p:sp>
         <p:nvSpPr>
-          <p:cNvPr id="54" name="Textebene 1…"/>
+          <p:cNvPr id="66" name="Textebene 1…"/>
           <p:cNvSpPr txBox="1"/>
           <p:nvPr>
             <p:ph type="body" sz="quarter" idx="1"/>
@@ -1099,7 +1728,7 @@
       </p:sp>
       <p:sp>
         <p:nvSpPr>
-          <p:cNvPr id="55" name="Foliennummer"/>
+          <p:cNvPr id="67" name="Foliennummer"/>
           <p:cNvSpPr txBox="1"/>
           <p:nvPr>
             <p:ph type="sldNum" sz="quarter" idx="2"/>
@@ -1161,7 +1790,7 @@
         <p:spPr>
           <a:xfrm>
             <a:off x="0" y="6707199"/>
-            <a:ext cx="12938125" cy="614117"/>
+            <a:ext cx="12938125" cy="614118"/>
           </a:xfrm>
           <a:prstGeom prst="rect">
             <a:avLst/>
@@ -1174,7 +1803,7 @@
           </a:ln>
         </p:spPr>
         <p:txBody>
-          <a:bodyPr lIns="45719" rIns="45719" anchor="ctr"/>
+          <a:bodyPr lIns="45718" tIns="45718" rIns="45718" bIns="45718" anchor="ctr"/>
           <a:lstStyle/>
           <a:p>
             <a:pPr algn="ctr">
@@ -1182,6 +1811,10 @@
                 <a:solidFill>
                   <a:srgbClr val="FFFFFF"/>
                 </a:solidFill>
+                <a:latin typeface="Arial"/>
+                <a:ea typeface="Arial"/>
+                <a:cs typeface="Arial"/>
+                <a:sym typeface="Arial"/>
               </a:defRPr>
             </a:pPr>
           </a:p>
@@ -1195,8 +1828,8 @@
         </p:nvSpPr>
         <p:spPr>
           <a:xfrm>
-            <a:off x="880587" y="715716"/>
-            <a:ext cx="11868856" cy="1"/>
+            <a:off x="880586" y="715716"/>
+            <a:ext cx="11868858" cy="1"/>
           </a:xfrm>
           <a:prstGeom prst="line">
             <a:avLst/>
@@ -1208,7 +1841,7 @@
           </a:ln>
         </p:spPr>
         <p:txBody>
-          <a:bodyPr lIns="45719" rIns="45719"/>
+          <a:bodyPr lIns="45718" tIns="45718" rIns="45718" bIns="45718"/>
           <a:lstStyle/>
           <a:p>
             <a:pPr/>
@@ -1234,7 +1867,7 @@
         <p:spPr>
           <a:xfrm>
             <a:off x="11523016" y="150773"/>
-            <a:ext cx="1226427" cy="453804"/>
+            <a:ext cx="1226428" cy="453804"/>
           </a:xfrm>
           <a:prstGeom prst="rect">
             <a:avLst/>
@@ -1252,7 +1885,7 @@
         </p:nvSpPr>
         <p:spPr>
           <a:xfrm>
-            <a:off x="880588" y="6827792"/>
+            <a:off x="880588" y="6827791"/>
             <a:ext cx="7675317" cy="400585"/>
           </a:xfrm>
           <a:prstGeom prst="rect">
@@ -1274,7 +1907,12 @@
           <a:lstStyle/>
           <a:p>
             <a:pPr>
-              <a:defRPr sz="1400"/>
+              <a:defRPr sz="1400">
+                <a:latin typeface="Arial"/>
+                <a:ea typeface="Arial"/>
+                <a:cs typeface="Arial"/>
+                <a:sym typeface="Arial"/>
+              </a:defRPr>
             </a:pPr>
             <a:r>
               <a:t>Kontakt: </a:t>
@@ -1282,11 +1920,11 @@
             <a:r>
               <a:rPr u="sng">
                 <a:solidFill>
-                  <a:srgbClr val="1111FF"/>
+                  <a:srgbClr val="0000FF"/>
                 </a:solidFill>
                 <a:uFill>
                   <a:solidFill>
-                    <a:srgbClr val="1111FF"/>
+                    <a:srgbClr val="0000FF"/>
                   </a:solidFill>
                 </a:uFill>
                 <a:hlinkClick r:id="rId3" invalidUrl="" action="" tgtFrame="" tooltip="" history="1" highlightClick="0" endSnd="0"/>
@@ -1299,11 +1937,11 @@
             <a:r>
               <a:rPr u="sng">
                 <a:solidFill>
-                  <a:srgbClr val="1111FF"/>
+                  <a:srgbClr val="0000FF"/>
                 </a:solidFill>
                 <a:uFill>
                   <a:solidFill>
-                    <a:srgbClr val="1111FF"/>
+                    <a:srgbClr val="0000FF"/>
                   </a:solidFill>
                 </a:uFill>
                 <a:hlinkClick r:id="rId4" invalidUrl="" action="" tgtFrame="" tooltip="" history="1" highlightClick="0" endSnd="0"/>
@@ -1318,7 +1956,12 @@
           </a:p>
           <a:p>
             <a:pPr>
-              <a:defRPr sz="1400"/>
+              <a:defRPr sz="1400">
+                <a:latin typeface="Arial"/>
+                <a:ea typeface="Arial"/>
+                <a:cs typeface="Arial"/>
+                <a:sym typeface="Arial"/>
+              </a:defRPr>
             </a:pPr>
             <a:r>
               <a:t>Titel der Veranstaltung, Ort &amp; Datum</a:t>
@@ -1335,7 +1978,7 @@
         <p:spPr>
           <a:xfrm>
             <a:off x="1" y="715716"/>
-            <a:ext cx="610968" cy="614117"/>
+            <a:ext cx="610968" cy="614118"/>
           </a:xfrm>
           <a:prstGeom prst="rect">
             <a:avLst/>
@@ -1348,7 +1991,7 @@
           </a:ln>
         </p:spPr>
         <p:txBody>
-          <a:bodyPr lIns="45719" rIns="45719" anchor="ctr"/>
+          <a:bodyPr lIns="45718" tIns="45718" rIns="45718" bIns="45718" anchor="ctr"/>
           <a:lstStyle/>
           <a:p>
             <a:pPr algn="ctr">
@@ -1356,6 +1999,10 @@
                 <a:solidFill>
                   <a:srgbClr val="FFFFFF"/>
                 </a:solidFill>
+                <a:latin typeface="Arial"/>
+                <a:ea typeface="Arial"/>
+                <a:cs typeface="Arial"/>
+                <a:sym typeface="Arial"/>
               </a:defRPr>
             </a:pPr>
           </a:p>
@@ -1363,16 +2010,16 @@
       </p:sp>
       <p:sp>
         <p:nvSpPr>
-          <p:cNvPr id="7" name="Titeltext"/>
+          <p:cNvPr id="7" name="Textebene 1…"/>
           <p:cNvSpPr txBox="1"/>
           <p:nvPr>
-            <p:ph type="title"/>
+            <p:ph type="body" idx="1"/>
           </p:nvPr>
         </p:nvSpPr>
         <p:spPr>
           <a:xfrm>
-            <a:off x="880588" y="884237"/>
-            <a:ext cx="11876400" cy="614117"/>
+            <a:off x="880588" y="349996"/>
+            <a:ext cx="10187500" cy="286722"/>
           </a:xfrm>
           <a:prstGeom prst="rect">
             <a:avLst/>
@@ -1387,30 +2034,54 @@
           </a:extLst>
         </p:spPr>
         <p:txBody>
-          <a:bodyPr lIns="0" tIns="0" rIns="0" bIns="0">
+          <a:bodyPr lIns="0" tIns="0" rIns="0" bIns="0" anchor="ctr">
             <a:normAutofit fontScale="100000" lnSpcReduction="0"/>
           </a:bodyPr>
           <a:lstStyle/>
           <a:p>
             <a:pPr/>
             <a:r>
-              <a:t>Titeltext</a:t>
+              <a:t>Textebene 1</a:t>
+            </a:r>
+          </a:p>
+          <a:p>
+            <a:pPr lvl="1"/>
+            <a:r>
+              <a:t>Textebene 2</a:t>
+            </a:r>
+          </a:p>
+          <a:p>
+            <a:pPr lvl="2"/>
+            <a:r>
+              <a:t>Textebene 3</a:t>
+            </a:r>
+          </a:p>
+          <a:p>
+            <a:pPr lvl="3"/>
+            <a:r>
+              <a:t>Textebene 4</a:t>
+            </a:r>
+          </a:p>
+          <a:p>
+            <a:pPr lvl="4"/>
+            <a:r>
+              <a:t>Textebene 5</a:t>
             </a:r>
           </a:p>
         </p:txBody>
       </p:sp>
       <p:sp>
         <p:nvSpPr>
-          <p:cNvPr id="8" name="Textebene 1…"/>
+          <p:cNvPr id="8" name="Titeltext"/>
           <p:cNvSpPr txBox="1"/>
           <p:nvPr>
-            <p:ph type="body" idx="1"/>
+            <p:ph type="title"/>
           </p:nvPr>
         </p:nvSpPr>
         <p:spPr>
           <a:xfrm>
-            <a:off x="880588" y="349997"/>
-            <a:ext cx="10187500" cy="286721"/>
+            <a:off x="880588" y="884237"/>
+            <a:ext cx="11876400" cy="1220402"/>
           </a:xfrm>
           <a:prstGeom prst="rect">
             <a:avLst/>
@@ -1425,45 +2096,130 @@
           </a:extLst>
         </p:spPr>
         <p:txBody>
-          <a:bodyPr lIns="0" tIns="0" rIns="0" bIns="0" anchor="ctr">
+          <a:bodyPr lIns="0" tIns="0" rIns="0" bIns="0">
             <a:normAutofit fontScale="100000" lnSpcReduction="0"/>
           </a:bodyPr>
           <a:lstStyle/>
           <a:p>
             <a:pPr/>
             <a:r>
-              <a:t>Textebene 1</a:t>
-            </a:r>
-          </a:p>
-          <a:p>
-            <a:pPr lvl="1"/>
-            <a:r>
-              <a:t>Textebene 2</a:t>
-            </a:r>
-          </a:p>
-          <a:p>
-            <a:pPr lvl="2"/>
-            <a:r>
-              <a:t>Textebene 3</a:t>
-            </a:r>
-          </a:p>
-          <a:p>
-            <a:pPr lvl="3"/>
-            <a:r>
-              <a:t>Textebene 4</a:t>
-            </a:r>
-          </a:p>
-          <a:p>
-            <a:pPr lvl="4"/>
-            <a:r>
-              <a:t>Textebene 5</a:t>
+              <a:t>Titeltext</a:t>
             </a:r>
           </a:p>
         </p:txBody>
       </p:sp>
       <p:sp>
         <p:nvSpPr>
-          <p:cNvPr id="9" name="Foliennummer"/>
+          <p:cNvPr id="9" name="Hockey"/>
+          <p:cNvSpPr/>
+          <p:nvPr/>
+        </p:nvSpPr>
+        <p:spPr>
+          <a:xfrm>
+            <a:off x="11784622" y="5265199"/>
+            <a:ext cx="1066406" cy="1983968"/>
+          </a:xfrm>
+          <a:custGeom>
+            <a:avLst/>
+            <a:gdLst/>
+            <a:ahLst/>
+            <a:cxnLst>
+              <a:cxn ang="0">
+                <a:pos x="wd2" y="hd2"/>
+              </a:cxn>
+              <a:cxn ang="5400000">
+                <a:pos x="wd2" y="hd2"/>
+              </a:cxn>
+              <a:cxn ang="10800000">
+                <a:pos x="wd2" y="hd2"/>
+              </a:cxn>
+              <a:cxn ang="16200000">
+                <a:pos x="wd2" y="hd2"/>
+              </a:cxn>
+            </a:cxnLst>
+            <a:rect l="0" t="0" r="r" b="b"/>
+            <a:pathLst>
+              <a:path w="21137" h="21405" fill="norm" stroke="1" extrusionOk="0">
+                <a:moveTo>
+                  <a:pt x="20360" y="4"/>
+                </a:moveTo>
+                <a:cubicBezTo>
+                  <a:pt x="20162" y="-10"/>
+                  <a:pt x="19920" y="15"/>
+                  <a:pt x="19622" y="104"/>
+                </a:cubicBezTo>
+                <a:lnTo>
+                  <a:pt x="8335" y="17757"/>
+                </a:lnTo>
+                <a:cubicBezTo>
+                  <a:pt x="8335" y="17757"/>
+                  <a:pt x="7581" y="18867"/>
+                  <a:pt x="4624" y="19356"/>
+                </a:cubicBezTo>
+                <a:lnTo>
+                  <a:pt x="627" y="20043"/>
+                </a:lnTo>
+                <a:cubicBezTo>
+                  <a:pt x="627" y="20043"/>
+                  <a:pt x="-463" y="20176"/>
+                  <a:pt x="230" y="20754"/>
+                </a:cubicBezTo>
+                <a:cubicBezTo>
+                  <a:pt x="230" y="20754"/>
+                  <a:pt x="666" y="21176"/>
+                  <a:pt x="1088" y="21302"/>
+                </a:cubicBezTo>
+                <a:cubicBezTo>
+                  <a:pt x="1088" y="21302"/>
+                  <a:pt x="1726" y="21590"/>
+                  <a:pt x="3453" y="21205"/>
+                </a:cubicBezTo>
+                <a:lnTo>
+                  <a:pt x="6406" y="20473"/>
+                </a:lnTo>
+                <a:cubicBezTo>
+                  <a:pt x="6406" y="20473"/>
+                  <a:pt x="8092" y="20229"/>
+                  <a:pt x="8903" y="19346"/>
+                </a:cubicBezTo>
+                <a:lnTo>
+                  <a:pt x="21137" y="432"/>
+                </a:lnTo>
+                <a:cubicBezTo>
+                  <a:pt x="21137" y="432"/>
+                  <a:pt x="20953" y="46"/>
+                  <a:pt x="20360" y="4"/>
+                </a:cubicBezTo>
+                <a:close/>
+              </a:path>
+            </a:pathLst>
+          </a:custGeom>
+          <a:solidFill>
+            <a:srgbClr val="FFFFFF"/>
+          </a:solidFill>
+          <a:ln w="25400">
+            <a:solidFill>
+              <a:srgbClr val="E2324C"/>
+            </a:solidFill>
+          </a:ln>
+        </p:spPr>
+        <p:txBody>
+          <a:bodyPr lIns="45718" tIns="45718" rIns="45718" bIns="45718" anchor="ctr"/>
+          <a:lstStyle/>
+          <a:p>
+            <a:pPr>
+              <a:defRPr>
+                <a:solidFill>
+                  <a:srgbClr val="B5160F"/>
+                </a:solidFill>
+              </a:defRPr>
+            </a:pPr>
+          </a:p>
+        </p:txBody>
+      </p:sp>
+      <p:sp>
+        <p:nvSpPr>
+          <p:cNvPr id="10" name="Foliennummer"/>
           <p:cNvSpPr txBox="1"/>
           <p:nvPr>
             <p:ph type="sldNum" sz="quarter" idx="2"/>
@@ -1491,6 +2247,10 @@
                 <a:solidFill>
                   <a:srgbClr val="FFFFFF"/>
                 </a:solidFill>
+                <a:latin typeface="Arial"/>
+                <a:ea typeface="Arial"/>
+                <a:cs typeface="Arial"/>
+                <a:sym typeface="Arial"/>
               </a:defRPr>
             </a:lvl1pPr>
           </a:lstStyle>
@@ -1775,7 +2535,7 @@
           <a:sym typeface="Arial"/>
         </a:defRPr>
       </a:lvl1pPr>
-      <a:lvl2pPr marL="609230" marR="0" indent="-249230" algn="l" defTabSz="914400" rtl="0" latinLnBrk="0">
+      <a:lvl2pPr marL="609230" marR="0" indent="-249229" algn="l" defTabSz="914400" rtl="0" latinLnBrk="0">
         <a:lnSpc>
           <a:spcPct val="100000"/>
         </a:lnSpc>
@@ -1801,7 +2561,7 @@
           <a:sym typeface="Arial"/>
         </a:defRPr>
       </a:lvl2pPr>
-      <a:lvl3pPr marL="989999" marR="0" indent="-269999" algn="l" defTabSz="914400" rtl="0" latinLnBrk="0">
+      <a:lvl3pPr marL="989998" marR="0" indent="-269999" algn="l" defTabSz="914400" rtl="0" latinLnBrk="0">
         <a:lnSpc>
           <a:spcPct val="100000"/>
         </a:lnSpc>
@@ -1827,7 +2587,7 @@
           <a:sym typeface="Arial"/>
         </a:defRPr>
       </a:lvl3pPr>
-      <a:lvl4pPr marL="1374545" marR="0" indent="-294545" algn="l" defTabSz="914400" rtl="0" latinLnBrk="0">
+      <a:lvl4pPr marL="1374544" marR="0" indent="-294545" algn="l" defTabSz="914400" rtl="0" latinLnBrk="0">
         <a:lnSpc>
           <a:spcPct val="100000"/>
         </a:lnSpc>
@@ -1853,7 +2613,7 @@
           <a:sym typeface="Arial"/>
         </a:defRPr>
       </a:lvl4pPr>
-      <a:lvl5pPr marL="0" marR="0" indent="1619999" algn="l" defTabSz="914400" rtl="0" latinLnBrk="0">
+      <a:lvl5pPr marL="0" marR="0" indent="0" algn="l" defTabSz="914400" rtl="0" latinLnBrk="0">
         <a:lnSpc>
           <a:spcPct val="100000"/>
         </a:lnSpc>
@@ -2011,7 +2771,7 @@
           <a:sym typeface="Arial"/>
         </a:defRPr>
       </a:lvl1pPr>
-      <a:lvl2pPr marL="0" marR="0" indent="648080" algn="ctr" defTabSz="648080" rtl="0" latinLnBrk="0">
+      <a:lvl2pPr marL="0" marR="0" indent="0" algn="ctr" defTabSz="648080" rtl="0" latinLnBrk="0">
         <a:lnSpc>
           <a:spcPct val="100000"/>
         </a:lnSpc>
@@ -2037,7 +2797,7 @@
           <a:sym typeface="Arial"/>
         </a:defRPr>
       </a:lvl2pPr>
-      <a:lvl3pPr marL="0" marR="0" indent="1296161" algn="ctr" defTabSz="648080" rtl="0" latinLnBrk="0">
+      <a:lvl3pPr marL="0" marR="0" indent="0" algn="ctr" defTabSz="648080" rtl="0" latinLnBrk="0">
         <a:lnSpc>
           <a:spcPct val="100000"/>
         </a:lnSpc>
@@ -2063,7 +2823,7 @@
           <a:sym typeface="Arial"/>
         </a:defRPr>
       </a:lvl3pPr>
-      <a:lvl4pPr marL="0" marR="0" indent="1944242" algn="ctr" defTabSz="648080" rtl="0" latinLnBrk="0">
+      <a:lvl4pPr marL="0" marR="0" indent="0" algn="ctr" defTabSz="648080" rtl="0" latinLnBrk="0">
         <a:lnSpc>
           <a:spcPct val="100000"/>
         </a:lnSpc>
@@ -2089,7 +2849,7 @@
           <a:sym typeface="Arial"/>
         </a:defRPr>
       </a:lvl4pPr>
-      <a:lvl5pPr marL="0" marR="0" indent="2592323" algn="ctr" defTabSz="648080" rtl="0" latinLnBrk="0">
+      <a:lvl5pPr marL="0" marR="0" indent="0" algn="ctr" defTabSz="648080" rtl="0" latinLnBrk="0">
         <a:lnSpc>
           <a:spcPct val="100000"/>
         </a:lnSpc>
@@ -2115,7 +2875,7 @@
           <a:sym typeface="Arial"/>
         </a:defRPr>
       </a:lvl5pPr>
-      <a:lvl6pPr marL="0" marR="0" indent="3240404" algn="ctr" defTabSz="648080" rtl="0" latinLnBrk="0">
+      <a:lvl6pPr marL="0" marR="0" indent="0" algn="ctr" defTabSz="648080" rtl="0" latinLnBrk="0">
         <a:lnSpc>
           <a:spcPct val="100000"/>
         </a:lnSpc>
@@ -2141,7 +2901,7 @@
           <a:sym typeface="Arial"/>
         </a:defRPr>
       </a:lvl6pPr>
-      <a:lvl7pPr marL="0" marR="0" indent="3888485" algn="ctr" defTabSz="648080" rtl="0" latinLnBrk="0">
+      <a:lvl7pPr marL="0" marR="0" indent="0" algn="ctr" defTabSz="648080" rtl="0" latinLnBrk="0">
         <a:lnSpc>
           <a:spcPct val="100000"/>
         </a:lnSpc>
@@ -2167,7 +2927,7 @@
           <a:sym typeface="Arial"/>
         </a:defRPr>
       </a:lvl7pPr>
-      <a:lvl8pPr marL="0" marR="0" indent="4536566" algn="ctr" defTabSz="648080" rtl="0" latinLnBrk="0">
+      <a:lvl8pPr marL="0" marR="0" indent="0" algn="ctr" defTabSz="648080" rtl="0" latinLnBrk="0">
         <a:lnSpc>
           <a:spcPct val="100000"/>
         </a:lnSpc>
@@ -2193,7 +2953,7 @@
           <a:sym typeface="Arial"/>
         </a:defRPr>
       </a:lvl8pPr>
-      <a:lvl9pPr marL="0" marR="0" indent="5184647" algn="ctr" defTabSz="648080" rtl="0" latinLnBrk="0">
+      <a:lvl9pPr marL="0" marR="0" indent="0" algn="ctr" defTabSz="648080" rtl="0" latinLnBrk="0">
         <a:lnSpc>
           <a:spcPct val="100000"/>
         </a:lnSpc>
@@ -2243,7 +3003,7 @@
       </p:grpSpPr>
       <p:sp>
         <p:nvSpPr>
-          <p:cNvPr id="64" name="Fußzeilenplatzhalter 2"/>
+          <p:cNvPr id="76" name="Fußzeilenplatzhalter 2"/>
           <p:cNvSpPr txBox="1"/>
           <p:nvPr/>
         </p:nvSpPr>
@@ -2271,12 +3031,22 @@
           <a:lstStyle/>
           <a:p>
             <a:pPr>
-              <a:defRPr sz="2000"/>
+              <a:defRPr sz="2000">
+                <a:latin typeface="Arial"/>
+                <a:ea typeface="Arial"/>
+                <a:cs typeface="Arial"/>
+                <a:sym typeface="Arial"/>
+              </a:defRPr>
             </a:pPr>
           </a:p>
           <a:p>
             <a:pPr>
-              <a:defRPr b="1" sz="2000"/>
+              <a:defRPr b="1" sz="2000">
+                <a:latin typeface="Arial"/>
+                <a:ea typeface="Arial"/>
+                <a:cs typeface="Arial"/>
+                <a:sym typeface="Arial"/>
+              </a:defRPr>
             </a:pPr>
             <a:r>
               <a:t>Antonia Lea Windisch</a:t>
@@ -2284,7 +3054,12 @@
           </a:p>
           <a:p>
             <a:pPr>
-              <a:defRPr b="1" sz="2000"/>
+              <a:defRPr b="1" sz="2000">
+                <a:latin typeface="Arial"/>
+                <a:ea typeface="Arial"/>
+                <a:cs typeface="Arial"/>
+                <a:sym typeface="Arial"/>
+              </a:defRPr>
             </a:pPr>
             <a:r>
               <a:t>Emily Thomas</a:t>
@@ -2292,7 +3067,12 @@
           </a:p>
           <a:p>
             <a:pPr>
-              <a:defRPr b="1" sz="2000"/>
+              <a:defRPr b="1" sz="2000">
+                <a:latin typeface="Arial"/>
+                <a:ea typeface="Arial"/>
+                <a:cs typeface="Arial"/>
+                <a:sym typeface="Arial"/>
+              </a:defRPr>
             </a:pPr>
             <a:r>
               <a:t>Vincent Jakl</a:t>
@@ -2300,12 +3080,22 @@
           </a:p>
           <a:p>
             <a:pPr>
-              <a:defRPr sz="2000"/>
+              <a:defRPr sz="2000">
+                <a:latin typeface="Arial"/>
+                <a:ea typeface="Arial"/>
+                <a:cs typeface="Arial"/>
+                <a:sym typeface="Arial"/>
+              </a:defRPr>
             </a:pPr>
           </a:p>
           <a:p>
             <a:pPr>
-              <a:defRPr sz="2000"/>
+              <a:defRPr sz="2000">
+                <a:latin typeface="Arial"/>
+                <a:ea typeface="Arial"/>
+                <a:cs typeface="Arial"/>
+                <a:sym typeface="Arial"/>
+              </a:defRPr>
             </a:pPr>
             <a:r>
               <a:t>Technische Universität Graz</a:t>
@@ -2313,7 +3103,12 @@
           </a:p>
           <a:p>
             <a:pPr>
-              <a:defRPr sz="2000"/>
+              <a:defRPr sz="2000">
+                <a:latin typeface="Arial"/>
+                <a:ea typeface="Arial"/>
+                <a:cs typeface="Arial"/>
+                <a:sym typeface="Arial"/>
+              </a:defRPr>
             </a:pPr>
             <a:r>
               <a:t>Inffeldgasse</a:t>
@@ -2321,7 +3116,12 @@
           </a:p>
           <a:p>
             <a:pPr>
-              <a:defRPr sz="2000"/>
+              <a:defRPr sz="2000">
+                <a:latin typeface="Arial"/>
+                <a:ea typeface="Arial"/>
+                <a:cs typeface="Arial"/>
+                <a:sym typeface="Arial"/>
+              </a:defRPr>
             </a:pPr>
             <a:r>
               <a:t>A 8010 Graz</a:t>
@@ -2331,7 +3131,7 @@
       </p:sp>
       <p:sp>
         <p:nvSpPr>
-          <p:cNvPr id="65" name="Titel 1"/>
+          <p:cNvPr id="77" name="Titel 1"/>
           <p:cNvSpPr txBox="1"/>
           <p:nvPr>
             <p:ph type="title"/>
@@ -2339,8 +3139,8 @@
         </p:nvSpPr>
         <p:spPr>
           <a:xfrm>
-            <a:off x="879471" y="1398588"/>
-            <a:ext cx="8658002" cy="2426400"/>
+            <a:off x="879471" y="1398587"/>
+            <a:ext cx="8658002" cy="2426401"/>
           </a:xfrm>
           <a:prstGeom prst="rect">
             <a:avLst/>
@@ -2353,6 +3153,451 @@
             <a:pPr/>
             <a:r>
               <a:t>Knowledge Discovery and Data Mining 1 - Phase 1 </a:t>
+            </a:r>
+          </a:p>
+        </p:txBody>
+      </p:sp>
+    </p:spTree>
+  </p:cSld>
+  <p:clrMapOvr>
+    <a:masterClrMapping/>
+  </p:clrMapOvr>
+  <p:transition xmlns:p14="http://schemas.microsoft.com/office/powerpoint/2010/main" spd="med" advClick="1"/>
+</p:sld>
+</file>
+
+<file path=ppt/slides/slide10.xml><?xml version="1.0" encoding="utf-8"?>
+<p:sld xmlns:a="http://schemas.openxmlformats.org/drawingml/2006/main" xmlns:r="http://schemas.openxmlformats.org/officeDocument/2006/relationships" xmlns:p="http://schemas.openxmlformats.org/presentationml/2006/main" xmlns:m="http://schemas.openxmlformats.org/officeDocument/2006/math" xmlns:a14="http://schemas.microsoft.com/office/drawing/2010/main" show="0" showMasterSp="1" showMasterPhAnim="1">
+  <p:cSld>
+    <p:spTree>
+      <p:nvGrpSpPr>
+        <p:cNvPr id="1" name=""/>
+        <p:cNvGrpSpPr/>
+        <p:nvPr/>
+      </p:nvGrpSpPr>
+      <p:grpSpPr>
+        <a:xfrm>
+          <a:off x="0" y="0"/>
+          <a:ext cx="0" cy="0"/>
+          <a:chOff x="0" y="0"/>
+          <a:chExt cx="0" cy="0"/>
+        </a:xfrm>
+      </p:grpSpPr>
+      <p:sp>
+        <p:nvSpPr>
+          <p:cNvPr id="115" name="Data cleaning"/>
+          <p:cNvSpPr txBox="1"/>
+          <p:nvPr>
+            <p:ph type="title"/>
+          </p:nvPr>
+        </p:nvSpPr>
+        <p:spPr>
+          <a:prstGeom prst="rect">
+            <a:avLst/>
+          </a:prstGeom>
+        </p:spPr>
+        <p:txBody>
+          <a:bodyPr/>
+          <a:lstStyle>
+            <a:lvl1pPr>
+              <a:defRPr>
+                <a:solidFill>
+                  <a:srgbClr val="040102"/>
+                </a:solidFill>
+              </a:defRPr>
+            </a:lvl1pPr>
+          </a:lstStyle>
+          <a:p>
+            <a:pPr/>
+            <a:r>
+              <a:t>Data cleaning</a:t>
+            </a:r>
+          </a:p>
+        </p:txBody>
+      </p:sp>
+      <p:sp>
+        <p:nvSpPr>
+          <p:cNvPr id="116" name="Zum Bearbeiten doppelklicken"/>
+          <p:cNvSpPr txBox="1"/>
+          <p:nvPr>
+            <p:ph type="body" sz="quarter" idx="1"/>
+          </p:nvPr>
+        </p:nvSpPr>
+        <p:spPr>
+          <a:xfrm>
+            <a:off x="880588" y="349996"/>
+            <a:ext cx="10187500" cy="286723"/>
+          </a:xfrm>
+          <a:prstGeom prst="rect">
+            <a:avLst/>
+          </a:prstGeom>
+        </p:spPr>
+        <p:txBody>
+          <a:bodyPr/>
+          <a:lstStyle/>
+          <a:p>
+            <a:pPr/>
+          </a:p>
+        </p:txBody>
+      </p:sp>
+      <p:sp>
+        <p:nvSpPr>
+          <p:cNvPr id="117" name="Foliennummer"/>
+          <p:cNvSpPr txBox="1"/>
+          <p:nvPr>
+            <p:ph type="sldNum" sz="quarter" idx="4294967295"/>
+          </p:nvPr>
+        </p:nvSpPr>
+        <p:spPr>
+          <a:xfrm>
+            <a:off x="239838" y="924083"/>
+            <a:ext cx="131293" cy="197384"/>
+          </a:xfrm>
+          <a:prstGeom prst="rect">
+            <a:avLst/>
+          </a:prstGeom>
+          <a:extLst>
+            <a:ext uri="{C572A759-6A51-4108-AA02-DFA0A04FC94B}">
+              <ma14:wrappingTextBoxFlag xmlns:ma14="http://schemas.microsoft.com/office/mac/drawingml/2011/main" val="1"/>
+            </a:ext>
+          </a:extLst>
+        </p:spPr>
+        <p:txBody>
+          <a:bodyPr/>
+          <a:lstStyle/>
+          <a:p>
+            <a:pPr/>
+            <a:fld id="{86CB4B4D-7CA3-9044-876B-883B54F8677D}" type="slidenum"/>
+          </a:p>
+        </p:txBody>
+      </p:sp>
+      <p:sp>
+        <p:nvSpPr>
+          <p:cNvPr id="118" name="Performance:…"/>
+          <p:cNvSpPr txBox="1"/>
+          <p:nvPr/>
+        </p:nvSpPr>
+        <p:spPr>
+          <a:xfrm>
+            <a:off x="500614" y="1778013"/>
+            <a:ext cx="12307164" cy="5298439"/>
+          </a:xfrm>
+          <a:prstGeom prst="rect">
+            <a:avLst/>
+          </a:prstGeom>
+          <a:ln w="12700">
+            <a:miter lim="400000"/>
+          </a:ln>
+          <a:extLst>
+            <a:ext uri="{C572A759-6A51-4108-AA02-DFA0A04FC94B}">
+              <ma14:wrappingTextBoxFlag xmlns:ma14="http://schemas.microsoft.com/office/mac/drawingml/2011/main" val="1"/>
+            </a:ext>
+          </a:extLst>
+        </p:spPr>
+        <p:txBody>
+          <a:bodyPr wrap="none" lIns="45718" tIns="45718" rIns="45718" bIns="45718">
+            <a:spAutoFit/>
+          </a:bodyPr>
+          <a:lstStyle/>
+          <a:p>
+            <a:pPr marL="260684" indent="-260684">
+              <a:buSzPct val="100000"/>
+              <a:buChar char="•"/>
+              <a:defRPr sz="2300"/>
+            </a:pPr>
+            <a:r>
+              <a:t>Performance:</a:t>
+            </a:r>
+          </a:p>
+          <a:p>
+            <a:pPr lvl="1" marL="641684" indent="-260684">
+              <a:buSzPct val="100000"/>
+              <a:buChar char="•"/>
+              <a:defRPr sz="2300"/>
+            </a:pPr>
+            <a:r>
+              <a:t>Puck touches, time between penalties and goals total were dropped due to inconsistency </a:t>
+            </a:r>
+          </a:p>
+          <a:p>
+            <a:pPr lvl="1" indent="228600">
+              <a:defRPr sz="2300"/>
+            </a:pPr>
+            <a:r>
+              <a:t>     with other columns </a:t>
+            </a:r>
+          </a:p>
+          <a:p>
+            <a:pPr lvl="1" marL="641684" indent="-260684">
+              <a:buSzPct val="100000"/>
+              <a:buChar char="•"/>
+              <a:defRPr sz="2300"/>
+            </a:pPr>
+            <a:r>
+              <a:t>puck possession time reformatted from minutes to seconds </a:t>
+            </a:r>
+          </a:p>
+          <a:p>
+            <a:pPr lvl="1" marL="641684" indent="-260684">
+              <a:buSzPct val="100000"/>
+              <a:buChar char="•"/>
+              <a:defRPr sz="2300"/>
+            </a:pPr>
+            <a:r>
+              <a:t>Set penalty minutes to 0 for players without any saved penalties </a:t>
+            </a:r>
+          </a:p>
+          <a:p>
+            <a:pPr lvl="1" marL="641684" indent="-260684">
+              <a:buSzPct val="100000"/>
+              <a:buChar char="•"/>
+              <a:defRPr sz="2300"/>
+            </a:pPr>
+            <a:r>
+              <a:t>Newly calculated shooting percentage since values beforehand didn’t seem </a:t>
+            </a:r>
+          </a:p>
+          <a:p>
+            <a:pPr lvl="2" indent="457200">
+              <a:defRPr sz="2300"/>
+            </a:pPr>
+            <a:r>
+              <a:t>  sensible -&gt; Equation: shooting percentage = goals/ number of shots * 100</a:t>
+            </a:r>
+          </a:p>
+          <a:p>
+            <a:pPr lvl="2" indent="457200">
+              <a:defRPr sz="2300"/>
+            </a:pPr>
+          </a:p>
+          <a:p>
+            <a:pPr marL="240631" indent="-240631">
+              <a:buSzPct val="100000"/>
+              <a:buChar char="•"/>
+            </a:pPr>
+            <a:r>
+              <a:rPr sz="2400"/>
+              <a:t>Medical:</a:t>
+            </a:r>
+            <a:r>
+              <a:t> </a:t>
+            </a:r>
+          </a:p>
+          <a:p>
+            <a:pPr lvl="1" marL="641684" indent="-260684">
+              <a:buSzPct val="100000"/>
+              <a:buChar char="•"/>
+            </a:pPr>
+          </a:p>
+          <a:p>
+            <a:pPr lvl="1" marL="641684" indent="-260684">
+              <a:buSzPct val="100000"/>
+              <a:buChar char="•"/>
+            </a:pPr>
+          </a:p>
+          <a:p>
+            <a:pPr lvl="1" marL="641684" indent="-260684">
+              <a:buSzPct val="100000"/>
+              <a:buChar char="•"/>
+            </a:pPr>
+          </a:p>
+          <a:p>
+            <a:pPr marL="260684" indent="-260684">
+              <a:buSzPct val="100000"/>
+              <a:buChar char="•"/>
+            </a:pPr>
+          </a:p>
+        </p:txBody>
+      </p:sp>
+    </p:spTree>
+  </p:cSld>
+  <p:clrMapOvr>
+    <a:masterClrMapping/>
+  </p:clrMapOvr>
+  <p:transition xmlns:p14="http://schemas.microsoft.com/office/powerpoint/2010/main" spd="med" advClick="1"/>
+</p:sld>
+</file>
+
+<file path=ppt/slides/slide11.xml><?xml version="1.0" encoding="utf-8"?>
+<p:sld xmlns:a="http://schemas.openxmlformats.org/drawingml/2006/main" xmlns:r="http://schemas.openxmlformats.org/officeDocument/2006/relationships" xmlns:p="http://schemas.openxmlformats.org/presentationml/2006/main" xmlns:m="http://schemas.openxmlformats.org/officeDocument/2006/math" xmlns:a14="http://schemas.microsoft.com/office/drawing/2010/main" showMasterSp="1" showMasterPhAnim="1">
+  <p:cSld>
+    <p:spTree>
+      <p:nvGrpSpPr>
+        <p:cNvPr id="1" name=""/>
+        <p:cNvGrpSpPr/>
+        <p:nvPr/>
+      </p:nvGrpSpPr>
+      <p:grpSpPr>
+        <a:xfrm>
+          <a:off x="0" y="0"/>
+          <a:ext cx="0" cy="0"/>
+          <a:chOff x="0" y="0"/>
+          <a:chExt cx="0" cy="0"/>
+        </a:xfrm>
+      </p:grpSpPr>
+      <p:sp>
+        <p:nvSpPr>
+          <p:cNvPr id="120" name="Most important findings"/>
+          <p:cNvSpPr txBox="1"/>
+          <p:nvPr>
+            <p:ph type="title"/>
+          </p:nvPr>
+        </p:nvSpPr>
+        <p:spPr>
+          <a:xfrm>
+            <a:off x="880588" y="884237"/>
+            <a:ext cx="3768153" cy="614118"/>
+          </a:xfrm>
+          <a:prstGeom prst="rect">
+            <a:avLst/>
+          </a:prstGeom>
+        </p:spPr>
+        <p:txBody>
+          <a:bodyPr/>
+          <a:lstStyle>
+            <a:lvl1pPr defTabSz="544387">
+              <a:defRPr sz="2856">
+                <a:solidFill>
+                  <a:srgbClr val="040102"/>
+                </a:solidFill>
+              </a:defRPr>
+            </a:lvl1pPr>
+          </a:lstStyle>
+          <a:p>
+            <a:pPr/>
+            <a:r>
+              <a:t>Most important findings</a:t>
+            </a:r>
+          </a:p>
+        </p:txBody>
+      </p:sp>
+      <p:sp>
+        <p:nvSpPr>
+          <p:cNvPr id="121" name="Zum Bearbeiten doppelklicken"/>
+          <p:cNvSpPr txBox="1"/>
+          <p:nvPr>
+            <p:ph type="body" sz="quarter" idx="1"/>
+          </p:nvPr>
+        </p:nvSpPr>
+        <p:spPr>
+          <a:xfrm>
+            <a:off x="880588" y="349996"/>
+            <a:ext cx="10187500" cy="286723"/>
+          </a:xfrm>
+          <a:prstGeom prst="rect">
+            <a:avLst/>
+          </a:prstGeom>
+        </p:spPr>
+        <p:txBody>
+          <a:bodyPr/>
+          <a:lstStyle/>
+          <a:p>
+            <a:pPr/>
+          </a:p>
+        </p:txBody>
+      </p:sp>
+      <p:sp>
+        <p:nvSpPr>
+          <p:cNvPr id="122" name="Foliennummer"/>
+          <p:cNvSpPr txBox="1"/>
+          <p:nvPr>
+            <p:ph type="sldNum" sz="quarter" idx="4294967295"/>
+          </p:nvPr>
+        </p:nvSpPr>
+        <p:spPr>
+          <a:xfrm>
+            <a:off x="241984" y="924083"/>
+            <a:ext cx="127001" cy="197384"/>
+          </a:xfrm>
+          <a:prstGeom prst="rect">
+            <a:avLst/>
+          </a:prstGeom>
+          <a:extLst>
+            <a:ext uri="{C572A759-6A51-4108-AA02-DFA0A04FC94B}">
+              <ma14:wrappingTextBoxFlag xmlns:ma14="http://schemas.microsoft.com/office/mac/drawingml/2011/main" val="1"/>
+            </a:ext>
+          </a:extLst>
+        </p:spPr>
+        <p:txBody>
+          <a:bodyPr/>
+          <a:lstStyle/>
+          <a:p>
+            <a:pPr/>
+            <a:fld id="{86CB4B4D-7CA3-9044-876B-883B54F8677D}" type="slidenum"/>
+          </a:p>
+        </p:txBody>
+      </p:sp>
+      <p:sp>
+        <p:nvSpPr>
+          <p:cNvPr id="123" name="Inconsistent columns…"/>
+          <p:cNvSpPr txBox="1"/>
+          <p:nvPr/>
+        </p:nvSpPr>
+        <p:spPr>
+          <a:xfrm>
+            <a:off x="487750" y="1778014"/>
+            <a:ext cx="11634833" cy="2453639"/>
+          </a:xfrm>
+          <a:prstGeom prst="rect">
+            <a:avLst/>
+          </a:prstGeom>
+          <a:ln w="12700">
+            <a:miter lim="400000"/>
+          </a:ln>
+          <a:extLst>
+            <a:ext uri="{C572A759-6A51-4108-AA02-DFA0A04FC94B}">
+              <ma14:wrappingTextBoxFlag xmlns:ma14="http://schemas.microsoft.com/office/mac/drawingml/2011/main" val="1"/>
+            </a:ext>
+          </a:extLst>
+        </p:spPr>
+        <p:txBody>
+          <a:bodyPr wrap="none" lIns="45718" tIns="45718" rIns="45718" bIns="45718">
+            <a:spAutoFit/>
+          </a:bodyPr>
+          <a:lstStyle/>
+          <a:p>
+            <a:pPr marL="260684" indent="-260684">
+              <a:buSzPct val="100000"/>
+              <a:buChar char="•"/>
+            </a:pPr>
+            <a:r>
+              <a:t>Inconsistent columns</a:t>
+            </a:r>
+          </a:p>
+          <a:p>
+            <a:pPr marL="260684" indent="-260684">
+              <a:buSzPct val="100000"/>
+              <a:buChar char="•"/>
+            </a:pPr>
+            <a:r>
+              <a:t>Missing data values, </a:t>
+            </a:r>
+          </a:p>
+          <a:p>
+            <a:pPr marL="260684" indent="-260684">
+              <a:buSzPct val="100000"/>
+              <a:buChar char="•"/>
+            </a:pPr>
+            <a:r>
+              <a:t>bizarre values such as age of 312  or draft year of 1850</a:t>
+            </a:r>
+          </a:p>
+          <a:p>
+            <a:pPr marL="260684" indent="-260684">
+              <a:buSzPct val="100000"/>
+              <a:buChar char="•"/>
+            </a:pPr>
+            <a:r>
+              <a:t>Correlation between </a:t>
+            </a:r>
+          </a:p>
+          <a:p>
+            <a:pPr marL="260684" indent="-260684">
+              <a:buSzPct val="100000"/>
+              <a:buChar char="•"/>
+            </a:pPr>
+            <a:r>
+              <a:t>Surprisingly no correlation between salary and years played or being captain </a:t>
             </a:r>
           </a:p>
         </p:txBody>
@@ -2385,10 +3630,10 @@
       </p:grpSpPr>
       <p:sp>
         <p:nvSpPr>
-          <p:cNvPr id="67" name="Foliennummernplatzhalter 5"/>
+          <p:cNvPr id="79" name="Foliennummernplatzhalter 5"/>
           <p:cNvSpPr txBox="1"/>
           <p:nvPr>
-            <p:ph type="sldNum" sz="quarter" idx="2"/>
+            <p:ph type="sldNum" sz="quarter" idx="4294967295"/>
           </p:nvPr>
         </p:nvSpPr>
         <p:spPr>
@@ -2416,24 +3661,28 @@
       </p:sp>
       <p:sp>
         <p:nvSpPr>
-          <p:cNvPr id="68" name="Titel 1"/>
+          <p:cNvPr id="80" name="Titel 1"/>
           <p:cNvSpPr txBox="1"/>
           <p:nvPr>
             <p:ph type="title"/>
           </p:nvPr>
         </p:nvSpPr>
         <p:spPr>
-          <a:xfrm>
-            <a:off x="880588" y="884237"/>
-            <a:ext cx="11876400" cy="614117"/>
-          </a:xfrm>
           <a:prstGeom prst="rect">
             <a:avLst/>
           </a:prstGeom>
         </p:spPr>
         <p:txBody>
           <a:bodyPr/>
-          <a:lstStyle/>
+          <a:lstStyle>
+            <a:lvl1pPr>
+              <a:defRPr>
+                <a:solidFill>
+                  <a:srgbClr val="0D0305"/>
+                </a:solidFill>
+              </a:defRPr>
+            </a:lvl1pPr>
+          </a:lstStyle>
           <a:p>
             <a:pPr/>
             <a:r>
@@ -2444,7 +3693,7 @@
       </p:sp>
       <p:sp>
         <p:nvSpPr>
-          <p:cNvPr id="69" name="Textplatzhalter 2"/>
+          <p:cNvPr id="81" name="Textplatzhalter 2"/>
           <p:cNvSpPr txBox="1"/>
           <p:nvPr>
             <p:ph type="body" sz="quarter" idx="1"/>
@@ -2452,8 +3701,8 @@
         </p:nvSpPr>
         <p:spPr>
           <a:xfrm>
-            <a:off x="880588" y="349997"/>
-            <a:ext cx="10187500" cy="286721"/>
+            <a:off x="880588" y="349996"/>
+            <a:ext cx="10187500" cy="286723"/>
           </a:xfrm>
           <a:prstGeom prst="rect">
             <a:avLst/>
@@ -2469,14 +3718,14 @@
       </p:sp>
       <p:sp>
         <p:nvSpPr>
-          <p:cNvPr id="70" name="Text"/>
+          <p:cNvPr id="82" name="Preserve as much information as possible…"/>
           <p:cNvSpPr txBox="1"/>
           <p:nvPr/>
         </p:nvSpPr>
         <p:spPr>
           <a:xfrm>
-            <a:off x="6109439" y="3422718"/>
-            <a:ext cx="709722" cy="474339"/>
+            <a:off x="712866" y="1663699"/>
+            <a:ext cx="12204299" cy="4815839"/>
           </a:xfrm>
           <a:prstGeom prst="rect">
             <a:avLst/>
@@ -2484,14 +3733,97 @@
           <a:ln w="12700">
             <a:miter lim="400000"/>
           </a:ln>
+          <a:extLst>
+            <a:ext uri="{C572A759-6A51-4108-AA02-DFA0A04FC94B}">
+              <ma14:wrappingTextBoxFlag xmlns:ma14="http://schemas.microsoft.com/office/mac/drawingml/2011/main" val="1"/>
+            </a:ext>
+          </a:extLst>
         </p:spPr>
         <p:txBody>
-          <a:bodyPr wrap="none" lIns="45719" rIns="45719">
+          <a:bodyPr wrap="none" lIns="45718" tIns="45718" rIns="45718" bIns="45718">
             <a:spAutoFit/>
           </a:bodyPr>
           <a:lstStyle/>
           <a:p>
+            <a:pPr marL="260684" indent="-260684">
+              <a:buSzPct val="100000"/>
+              <a:buChar char="•"/>
+            </a:pPr>
+            <a:r>
+              <a:t>Preserve as much information as possible</a:t>
+            </a:r>
+          </a:p>
+          <a:p>
+            <a:pPr marL="260684" indent="-260684">
+              <a:buSzPct val="100000"/>
+              <a:buChar char="•"/>
+            </a:pPr>
+            <a:r>
+              <a:t>For contradictory columns, keep the more relevant one </a:t>
+            </a:r>
+          </a:p>
+          <a:p>
+            <a:pPr marL="260684" indent="-260684">
+              <a:buSzPct val="100000"/>
+              <a:buChar char="•"/>
+            </a:pPr>
+            <a:r>
+              <a:t>Use domain knowledge but due to synthesized data set accept some values one wouldn’t normally expect </a:t>
+            </a:r>
+          </a:p>
+          <a:p>
+            <a:pPr marL="260684" indent="-260684">
+              <a:buSzPct val="100000"/>
+              <a:buChar char="•"/>
+            </a:pPr>
+            <a:r>
+              <a:t>Diversity encouraged </a:t>
+            </a:r>
+          </a:p>
+          <a:p>
             <a:pPr/>
+          </a:p>
+          <a:p>
+            <a:pPr marL="260684" indent="-260684">
+              <a:buSzPct val="100000"/>
+              <a:buChar char="•"/>
+            </a:pPr>
+            <a:r>
+              <a:t>Some assumptions taken were: </a:t>
+            </a:r>
+          </a:p>
+          <a:p>
+            <a:pPr lvl="1" marL="641684" indent="-260684">
+              <a:buSzPct val="100000"/>
+              <a:buChar char="•"/>
+            </a:pPr>
+            <a:r>
+              <a:t>Time on ice portrayed in hours while power play time in seconds since a lot of</a:t>
+            </a:r>
+          </a:p>
+          <a:p>
+            <a:pPr lvl="1" indent="228600"/>
+            <a:r>
+              <a:t>     people have higher power play time than time on ice</a:t>
+            </a:r>
+          </a:p>
+          <a:p>
+            <a:pPr lvl="1" marL="641684" indent="-260684">
+              <a:buSzPct val="100000"/>
+              <a:buChar char="•"/>
+            </a:pPr>
+            <a:r>
+              <a:t>Penalty kill time portrayed in minutes and changed to seconds </a:t>
+            </a:r>
+          </a:p>
+          <a:p>
+            <a:pPr lvl="1" marL="641684" indent="-260684">
+              <a:buSzPct val="100000"/>
+              <a:buChar char="•"/>
+            </a:pPr>
+            <a:r>
+              <a:t> </a:t>
+            </a:r>
           </a:p>
         </p:txBody>
       </p:sp>
@@ -2523,48 +3855,49 @@
       </p:grpSpPr>
       <p:sp>
         <p:nvSpPr>
-          <p:cNvPr id="72" name="Foliennummernplatzhalter 5"/>
+          <p:cNvPr id="84" name="Preprocessing"/>
           <p:cNvSpPr txBox="1"/>
           <p:nvPr>
-            <p:ph type="sldNum" sz="quarter" idx="2"/>
+            <p:ph type="title"/>
           </p:nvPr>
         </p:nvSpPr>
         <p:spPr>
           <a:xfrm>
-            <a:off x="241985" y="924083"/>
-            <a:ext cx="127001" cy="197384"/>
+            <a:off x="880588" y="884237"/>
+            <a:ext cx="4488200" cy="614118"/>
           </a:xfrm>
           <a:prstGeom prst="rect">
             <a:avLst/>
           </a:prstGeom>
-          <a:extLst>
-            <a:ext uri="{C572A759-6A51-4108-AA02-DFA0A04FC94B}">
-              <ma14:wrappingTextBoxFlag xmlns:ma14="http://schemas.microsoft.com/office/mac/drawingml/2011/main" val="1"/>
-            </a:ext>
-          </a:extLst>
         </p:spPr>
         <p:txBody>
           <a:bodyPr/>
           <a:lstStyle/>
           <a:p>
             <a:pPr/>
-            <a:fld id="{86CB4B4D-7CA3-9044-876B-883B54F8677D}" type="slidenum"/>
+            <a:r>
+              <a:rPr>
+                <a:solidFill>
+                  <a:srgbClr val="000000"/>
+                </a:solidFill>
+              </a:rPr>
+              <a:t>Preprocessing</a:t>
+            </a:r>
+            <a:r>
+              <a:t> </a:t>
+            </a:r>
           </a:p>
         </p:txBody>
       </p:sp>
       <p:sp>
         <p:nvSpPr>
-          <p:cNvPr id="73" name="Textplatzhalter 1"/>
+          <p:cNvPr id="85" name="Zum Bearbeiten doppelklicken"/>
           <p:cNvSpPr txBox="1"/>
           <p:nvPr>
             <p:ph type="body" sz="quarter" idx="1"/>
           </p:nvPr>
         </p:nvSpPr>
         <p:spPr>
-          <a:xfrm>
-            <a:off x="880588" y="349997"/>
-            <a:ext cx="10187500" cy="286721"/>
-          </a:xfrm>
           <a:prstGeom prst="rect">
             <a:avLst/>
           </a:prstGeom>
@@ -2579,42 +3912,14 @@
       </p:sp>
       <p:sp>
         <p:nvSpPr>
-          <p:cNvPr id="74" name="Titel 3"/>
-          <p:cNvSpPr txBox="1"/>
-          <p:nvPr>
-            <p:ph type="title"/>
-          </p:nvPr>
-        </p:nvSpPr>
-        <p:spPr>
-          <a:xfrm>
-            <a:off x="880588" y="884237"/>
-            <a:ext cx="11876400" cy="1220401"/>
-          </a:xfrm>
-          <a:prstGeom prst="rect">
-            <a:avLst/>
-          </a:prstGeom>
-        </p:spPr>
-        <p:txBody>
-          <a:bodyPr/>
-          <a:lstStyle/>
-          <a:p>
-            <a:pPr/>
-            <a:r>
-              <a:t>Preprocessing</a:t>
-            </a:r>
-          </a:p>
-        </p:txBody>
-      </p:sp>
-      <p:sp>
-        <p:nvSpPr>
-          <p:cNvPr id="75" name="Discrepancy in depiction of gender values: f/ female , m/male…"/>
+          <p:cNvPr id="86" name="Discrepancies found:…"/>
           <p:cNvSpPr txBox="1"/>
           <p:nvPr/>
         </p:nvSpPr>
         <p:spPr>
           <a:xfrm>
-            <a:off x="521056" y="1621719"/>
-            <a:ext cx="11395731" cy="3669031"/>
+            <a:off x="847950" y="1663699"/>
+            <a:ext cx="6959924" cy="3495039"/>
           </a:xfrm>
           <a:prstGeom prst="rect">
             <a:avLst/>
@@ -2629,154 +3934,79 @@
           </a:extLst>
         </p:spPr>
         <p:txBody>
-          <a:bodyPr wrap="none" lIns="45719" rIns="45719">
+          <a:bodyPr wrap="none" lIns="45718" tIns="45718" rIns="45718" bIns="45718">
             <a:spAutoFit/>
           </a:bodyPr>
           <a:lstStyle/>
           <a:p>
-            <a:pPr marL="228600" indent="-228600" defTabSz="914400">
-              <a:lnSpc>
-                <a:spcPct val="90000"/>
-              </a:lnSpc>
-              <a:spcBef>
-                <a:spcPts val="1000"/>
-              </a:spcBef>
+            <a:pPr>
+              <a:defRPr sz="2500"/>
+            </a:pPr>
+            <a:r>
+              <a:t>Discrepancies found: </a:t>
+            </a:r>
+          </a:p>
+          <a:p>
+            <a:pPr marL="260684" indent="-260684">
               <a:buSzPct val="100000"/>
-              <a:buFont typeface="Arial"/>
               <a:buChar char="•"/>
-              <a:defRPr sz="2400">
-                <a:latin typeface="Aptos"/>
-                <a:ea typeface="Aptos"/>
-                <a:cs typeface="Aptos"/>
-                <a:sym typeface="Aptos"/>
-              </a:defRPr>
-            </a:pPr>
-            <a:r>
-              <a:t>Discrepancy in depiction of gender values: f/ female , m/male</a:t>
-            </a:r>
-          </a:p>
-          <a:p>
-            <a:pPr defTabSz="914400">
-              <a:lnSpc>
-                <a:spcPct val="90000"/>
-              </a:lnSpc>
-              <a:spcBef>
-                <a:spcPts val="1000"/>
-              </a:spcBef>
-              <a:defRPr sz="2400">
-                <a:latin typeface="Aptos"/>
-                <a:ea typeface="Aptos"/>
-                <a:cs typeface="Aptos"/>
-                <a:sym typeface="Aptos"/>
-              </a:defRPr>
-            </a:pPr>
-            <a:r>
-              <a:t>-&gt; Normalized gender mapping </a:t>
-            </a:r>
-          </a:p>
-          <a:p>
-            <a:pPr marL="228600" indent="-228600" defTabSz="914400">
-              <a:lnSpc>
-                <a:spcPct val="90000"/>
-              </a:lnSpc>
-              <a:spcBef>
-                <a:spcPts val="1000"/>
-              </a:spcBef>
+              <a:defRPr sz="2500"/>
+            </a:pPr>
+            <a:r>
+              <a:t>Depiction of gender values: f/female , m/male</a:t>
+            </a:r>
+          </a:p>
+          <a:p>
+            <a:pPr marL="260684" indent="-260684">
               <a:buSzPct val="100000"/>
-              <a:buFont typeface="Arial"/>
               <a:buChar char="•"/>
-              <a:defRPr sz="2400">
-                <a:latin typeface="Aptos"/>
-                <a:ea typeface="Aptos"/>
-                <a:cs typeface="Aptos"/>
-                <a:sym typeface="Aptos"/>
-              </a:defRPr>
-            </a:pPr>
-            <a:r>
-              <a:t>Discrepancy in depiction of city and country names: Austria / austria etc.</a:t>
-            </a:r>
-          </a:p>
-          <a:p>
-            <a:pPr defTabSz="914400">
-              <a:lnSpc>
-                <a:spcPct val="90000"/>
-              </a:lnSpc>
-              <a:spcBef>
-                <a:spcPts val="1000"/>
-              </a:spcBef>
-              <a:defRPr sz="2400">
-                <a:latin typeface="Aptos"/>
-                <a:ea typeface="Aptos"/>
-                <a:cs typeface="Aptos"/>
-                <a:sym typeface="Aptos"/>
-              </a:defRPr>
-            </a:pPr>
-            <a:r>
-              <a:t>-&gt; Normalized values to lowercase </a:t>
-            </a:r>
-          </a:p>
-          <a:p>
-            <a:pPr marL="228600" indent="-228600" defTabSz="914400">
-              <a:lnSpc>
-                <a:spcPct val="90000"/>
-              </a:lnSpc>
-              <a:spcBef>
-                <a:spcPts val="1000"/>
-              </a:spcBef>
+              <a:defRPr sz="2500"/>
+            </a:pPr>
+            <a:r>
+              <a:t>Country and City names: Austria / austria</a:t>
+            </a:r>
+          </a:p>
+          <a:p>
+            <a:pPr marL="260684" indent="-260684">
               <a:buSzPct val="100000"/>
-              <a:buFont typeface="Arial"/>
               <a:buChar char="•"/>
-              <a:defRPr sz="2400">
-                <a:latin typeface="Aptos"/>
-                <a:ea typeface="Aptos"/>
-                <a:cs typeface="Aptos"/>
-                <a:sym typeface="Aptos"/>
-              </a:defRPr>
-            </a:pPr>
-            <a:r>
-              <a:t>Internationals IDs from dataset id_card_0 refactored from roman to Arab numerals</a:t>
-            </a:r>
-          </a:p>
-          <a:p>
-            <a:pPr marL="228600" indent="-228600" defTabSz="914400">
-              <a:lnSpc>
-                <a:spcPct val="90000"/>
-              </a:lnSpc>
-              <a:spcBef>
-                <a:spcPts val="1000"/>
-              </a:spcBef>
+              <a:defRPr sz="2500"/>
+            </a:pPr>
+            <a:r>
+              <a:t>Weight and height: kg/no value, cm/m/no value</a:t>
+            </a:r>
+          </a:p>
+          <a:p>
+            <a:pPr marL="260684" indent="-260684">
               <a:buSzPct val="100000"/>
-              <a:buFont typeface="Arial"/>
               <a:buChar char="•"/>
-              <a:defRPr sz="2400">
-                <a:latin typeface="Aptos"/>
-                <a:ea typeface="Aptos"/>
-                <a:cs typeface="Aptos"/>
-                <a:sym typeface="Aptos"/>
-              </a:defRPr>
-            </a:pPr>
-            <a:r>
-              <a:t>Suspicious amount of first names ended on „ius“, interpreted that as an mistake</a:t>
-            </a:r>
-          </a:p>
-          <a:p>
-            <a:pPr defTabSz="914400">
-              <a:lnSpc>
-                <a:spcPct val="90000"/>
-              </a:lnSpc>
-              <a:spcBef>
-                <a:spcPts val="1000"/>
-              </a:spcBef>
-              <a:defRPr sz="2400">
-                <a:latin typeface="Aptos"/>
-                <a:ea typeface="Aptos"/>
-                <a:cs typeface="Aptos"/>
-                <a:sym typeface="Aptos"/>
-              </a:defRPr>
-            </a:pPr>
-            <a:r>
-              <a:t>-&gt; removed all the ius endings</a:t>
-            </a:r>
+              <a:defRPr sz="2500"/>
+            </a:pPr>
+            <a:r>
+              <a:t>Fitness level </a:t>
+            </a:r>
+          </a:p>
+          <a:p>
+            <a:pPr marL="260684" indent="-260684">
+              <a:buSzPct val="100000"/>
+              <a:buChar char="•"/>
+              <a:defRPr sz="2500"/>
+            </a:pPr>
+            <a:r>
+              <a:t>Percentage sign in body fat</a:t>
+            </a:r>
+          </a:p>
+          <a:p>
+            <a:pPr>
+              <a:defRPr sz="2300"/>
+            </a:pPr>
+          </a:p>
+          <a:p>
+            <a:pPr marL="260684" indent="-260684">
+              <a:buSzPct val="100000"/>
+              <a:buChar char="•"/>
+              <a:defRPr sz="2500"/>
+            </a:pPr>
           </a:p>
         </p:txBody>
       </p:sp>
@@ -2808,20 +4038,42 @@
       </p:grpSpPr>
       <p:sp>
         <p:nvSpPr>
-          <p:cNvPr id="77" name="Foliennummernplatzhalter 5"/>
+          <p:cNvPr id="88" name="Zum Bearbeiten doppelklicken"/>
           <p:cNvSpPr txBox="1"/>
           <p:nvPr>
-            <p:ph type="sldNum" sz="quarter" idx="2"/>
+            <p:ph type="body" sz="quarter" idx="1"/>
           </p:nvPr>
         </p:nvSpPr>
         <p:spPr>
+          <a:prstGeom prst="rect">
+            <a:avLst/>
+          </a:prstGeom>
+        </p:spPr>
+        <p:txBody>
+          <a:bodyPr/>
+          <a:lstStyle/>
+          <a:p>
+            <a:pPr/>
+          </a:p>
+        </p:txBody>
+      </p:sp>
+      <p:sp>
+        <p:nvSpPr>
+          <p:cNvPr id="89" name="Identified quality issues in the data:…"/>
+          <p:cNvSpPr txBox="1"/>
+          <p:nvPr/>
+        </p:nvSpPr>
+        <p:spPr>
           <a:xfrm>
-            <a:off x="241985" y="924083"/>
-            <a:ext cx="127001" cy="197384"/>
+            <a:off x="827492" y="1642958"/>
+            <a:ext cx="11273615" cy="3253739"/>
           </a:xfrm>
           <a:prstGeom prst="rect">
             <a:avLst/>
           </a:prstGeom>
+          <a:ln w="12700">
+            <a:miter lim="400000"/>
+          </a:ln>
           <a:extLst>
             <a:ext uri="{C572A759-6A51-4108-AA02-DFA0A04FC94B}">
               <ma14:wrappingTextBoxFlag xmlns:ma14="http://schemas.microsoft.com/office/mac/drawingml/2011/main" val="1"/>
@@ -2829,64 +4081,125 @@
           </a:extLst>
         </p:spPr>
         <p:txBody>
-          <a:bodyPr/>
+          <a:bodyPr wrap="none" lIns="45718" tIns="45718" rIns="45718" bIns="45718">
+            <a:spAutoFit/>
+          </a:bodyPr>
           <a:lstStyle/>
           <a:p>
+            <a:pPr>
+              <a:defRPr sz="2500"/>
+            </a:pPr>
+            <a:r>
+              <a:t>Identified quality issues in the data:</a:t>
+            </a:r>
+          </a:p>
+          <a:p>
+            <a:pPr marL="260684" indent="-260684">
+              <a:buSzPct val="100000"/>
+              <a:buChar char="•"/>
+              <a:defRPr sz="2500"/>
+            </a:pPr>
+            <a:r>
+              <a:t>Save percentages greater than 100</a:t>
+            </a:r>
+          </a:p>
+          <a:p>
+            <a:pPr marL="260684" indent="-260684">
+              <a:buSzPct val="100000"/>
+              <a:buChar char="•"/>
+              <a:defRPr sz="2500"/>
+            </a:pPr>
+            <a:r>
+              <a:t>Suspicious amount of first names ending in „ius“</a:t>
+            </a:r>
+          </a:p>
+          <a:p>
+            <a:pPr marL="260684" indent="-260684">
+              <a:buSzPct val="100000"/>
+              <a:buChar char="•"/>
+              <a:defRPr sz="2500"/>
+            </a:pPr>
+            <a:r>
+              <a:t>International ids in roman numerals</a:t>
+            </a:r>
+          </a:p>
+          <a:p>
+            <a:pPr marL="260684" indent="-260684">
+              <a:buSzPct val="100000"/>
+              <a:buChar char="•"/>
+              <a:defRPr sz="2500"/>
+            </a:pPr>
+            <a:r>
+              <a:t>37 rows with missing values</a:t>
+            </a:r>
+          </a:p>
+          <a:p>
+            <a:pPr marL="260684" indent="-260684">
+              <a:buSzPct val="100000"/>
+              <a:buChar char="•"/>
+              <a:defRPr sz="2500"/>
+            </a:pPr>
+            <a:r>
+              <a:t>Age outliers found upon inspection, decided on upper bound of oldest person </a:t>
+            </a:r>
+          </a:p>
+          <a:p>
             <a:pPr/>
-            <a:fld id="{86CB4B4D-7CA3-9044-876B-883B54F8677D}" type="slidenum"/>
+            <a:r>
+              <a:rPr sz="2500"/>
+              <a:t>   alive due to diversity encouragement</a:t>
+            </a:r>
+            <a:r>
+              <a:t> </a:t>
+            </a:r>
           </a:p>
         </p:txBody>
       </p:sp>
       <p:sp>
         <p:nvSpPr>
-          <p:cNvPr id="78" name="Titel 1"/>
+          <p:cNvPr id="90" name="Preprocessing"/>
           <p:cNvSpPr txBox="1"/>
-          <p:nvPr>
-            <p:ph type="title"/>
-          </p:nvPr>
+          <p:nvPr/>
         </p:nvSpPr>
         <p:spPr>
           <a:xfrm>
-            <a:off x="880588" y="884237"/>
-            <a:ext cx="11876400" cy="614117"/>
+            <a:off x="850161" y="853532"/>
+            <a:ext cx="3009837" cy="572613"/>
           </a:xfrm>
           <a:prstGeom prst="rect">
             <a:avLst/>
           </a:prstGeom>
+          <a:ln w="12700">
+            <a:miter lim="400000"/>
+          </a:ln>
+          <a:extLst>
+            <a:ext uri="{C572A759-6A51-4108-AA02-DFA0A04FC94B}">
+              <ma14:wrappingTextBoxFlag xmlns:ma14="http://schemas.microsoft.com/office/mac/drawingml/2011/main" val="1"/>
+            </a:ext>
+          </a:extLst>
         </p:spPr>
         <p:txBody>
-          <a:bodyPr/>
-          <a:lstStyle/>
+          <a:bodyPr lIns="45718" tIns="45718" rIns="45718" bIns="45718">
+            <a:spAutoFit/>
+          </a:bodyPr>
+          <a:lstStyle>
+            <a:lvl1pPr>
+              <a:lnSpc>
+                <a:spcPct val="90000"/>
+              </a:lnSpc>
+              <a:defRPr sz="3400">
+                <a:latin typeface="Arial"/>
+                <a:ea typeface="Arial"/>
+                <a:cs typeface="Arial"/>
+                <a:sym typeface="Arial"/>
+              </a:defRPr>
+            </a:lvl1pPr>
+          </a:lstStyle>
           <a:p>
             <a:pPr/>
             <a:r>
-              <a:t>Data relationships</a:t>
-            </a:r>
-          </a:p>
-        </p:txBody>
-      </p:sp>
-      <p:sp>
-        <p:nvSpPr>
-          <p:cNvPr id="79" name="Textplatzhalter 2"/>
-          <p:cNvSpPr txBox="1"/>
-          <p:nvPr>
-            <p:ph type="body" sz="quarter" idx="1"/>
-          </p:nvPr>
-        </p:nvSpPr>
-        <p:spPr>
-          <a:xfrm>
-            <a:off x="880588" y="349997"/>
-            <a:ext cx="10187500" cy="286721"/>
-          </a:xfrm>
-          <a:prstGeom prst="rect">
-            <a:avLst/>
-          </a:prstGeom>
-        </p:spPr>
-        <p:txBody>
-          <a:bodyPr/>
-          <a:lstStyle/>
-          <a:p>
-            <a:pPr/>
+              <a:t>Preprocessing</a:t>
+            </a:r>
           </a:p>
         </p:txBody>
       </p:sp>
@@ -2918,20 +4231,103 @@
       </p:grpSpPr>
       <p:sp>
         <p:nvSpPr>
-          <p:cNvPr id="81" name="Foliennummernplatzhalter 5"/>
+          <p:cNvPr id="92" name="Data relationship"/>
           <p:cNvSpPr txBox="1"/>
           <p:nvPr>
-            <p:ph type="sldNum" sz="quarter" idx="2"/>
+            <p:ph type="title"/>
           </p:nvPr>
         </p:nvSpPr>
         <p:spPr>
           <a:xfrm>
-            <a:off x="241985" y="924083"/>
-            <a:ext cx="127001" cy="197384"/>
+            <a:off x="880588" y="884237"/>
+            <a:ext cx="3137458" cy="614118"/>
           </a:xfrm>
           <a:prstGeom prst="rect">
             <a:avLst/>
           </a:prstGeom>
+        </p:spPr>
+        <p:txBody>
+          <a:bodyPr/>
+          <a:lstStyle>
+            <a:lvl1pPr defTabSz="622156">
+              <a:defRPr sz="3264"/>
+            </a:lvl1pPr>
+          </a:lstStyle>
+          <a:p>
+            <a:pPr/>
+            <a:r>
+              <a:t>Data relationship</a:t>
+            </a:r>
+          </a:p>
+        </p:txBody>
+      </p:sp>
+      <p:sp>
+        <p:nvSpPr>
+          <p:cNvPr id="93" name="Zum Bearbeiten doppelklicken"/>
+          <p:cNvSpPr txBox="1"/>
+          <p:nvPr>
+            <p:ph type="body" sz="quarter" idx="1"/>
+          </p:nvPr>
+        </p:nvSpPr>
+        <p:spPr>
+          <a:prstGeom prst="rect">
+            <a:avLst/>
+          </a:prstGeom>
+        </p:spPr>
+        <p:txBody>
+          <a:bodyPr/>
+          <a:lstStyle/>
+          <a:p>
+            <a:pPr/>
+          </a:p>
+        </p:txBody>
+      </p:sp>
+      <p:pic>
+        <p:nvPicPr>
+          <p:cNvPr id="94" name="heatmap_white.png" descr="heatmap_white.png"/>
+          <p:cNvPicPr>
+            <a:picLocks noChangeAspect="1"/>
+          </p:cNvPicPr>
+          <p:nvPr/>
+        </p:nvPicPr>
+        <p:blipFill>
+          <a:blip r:embed="rId2">
+            <a:extLst/>
+          </a:blip>
+          <a:stretch>
+            <a:fillRect/>
+          </a:stretch>
+        </p:blipFill>
+        <p:spPr>
+          <a:xfrm>
+            <a:off x="6488587" y="1224015"/>
+            <a:ext cx="5913258" cy="5098505"/>
+          </a:xfrm>
+          <a:prstGeom prst="rect">
+            <a:avLst/>
+          </a:prstGeom>
+          <a:ln w="12700">
+            <a:miter lim="400000"/>
+          </a:ln>
+        </p:spPr>
+      </p:pic>
+      <p:sp>
+        <p:nvSpPr>
+          <p:cNvPr id="95" name="Visualize correlation between columns…"/>
+          <p:cNvSpPr txBox="1"/>
+          <p:nvPr/>
+        </p:nvSpPr>
+        <p:spPr>
+          <a:xfrm>
+            <a:off x="822221" y="1663699"/>
+            <a:ext cx="5809971" cy="802639"/>
+          </a:xfrm>
+          <a:prstGeom prst="rect">
+            <a:avLst/>
+          </a:prstGeom>
+          <a:ln w="12700">
+            <a:miter lim="400000"/>
+          </a:ln>
           <a:extLst>
             <a:ext uri="{C572A759-6A51-4108-AA02-DFA0A04FC94B}">
               <ma14:wrappingTextBoxFlag xmlns:ma14="http://schemas.microsoft.com/office/mac/drawingml/2011/main" val="1"/>
@@ -2939,64 +4335,136 @@
           </a:extLst>
         </p:spPr>
         <p:txBody>
-          <a:bodyPr/>
+          <a:bodyPr lIns="45718" tIns="45718" rIns="45718" bIns="45718">
+            <a:spAutoFit/>
+          </a:bodyPr>
           <a:lstStyle/>
           <a:p>
-            <a:pPr/>
-            <a:fld id="{86CB4B4D-7CA3-9044-876B-883B54F8677D}" type="slidenum"/>
+            <a:pPr>
+              <a:defRPr sz="2300"/>
+            </a:pPr>
+            <a:r>
+              <a:t>Visualize correlation between columns</a:t>
+            </a:r>
+          </a:p>
+          <a:p>
+            <a:pPr>
+              <a:defRPr sz="2300"/>
+            </a:pPr>
+            <a:r>
+              <a:t>using a Heatmap</a:t>
+            </a:r>
           </a:p>
         </p:txBody>
       </p:sp>
       <p:sp>
         <p:nvSpPr>
-          <p:cNvPr id="82" name="Titel 1"/>
+          <p:cNvPr id="96" name="Columns with highest correlation:"/>
           <p:cNvSpPr txBox="1"/>
-          <p:nvPr>
-            <p:ph type="title"/>
-          </p:nvPr>
+          <p:nvPr/>
         </p:nvSpPr>
         <p:spPr>
           <a:xfrm>
-            <a:off x="880588" y="884237"/>
-            <a:ext cx="11876400" cy="1220401"/>
+            <a:off x="809357" y="2915611"/>
+            <a:ext cx="4406481" cy="840739"/>
           </a:xfrm>
           <a:prstGeom prst="rect">
             <a:avLst/>
           </a:prstGeom>
+          <a:ln w="12700">
+            <a:miter lim="400000"/>
+          </a:ln>
+          <a:extLst>
+            <a:ext uri="{C572A759-6A51-4108-AA02-DFA0A04FC94B}">
+              <ma14:wrappingTextBoxFlag xmlns:ma14="http://schemas.microsoft.com/office/mac/drawingml/2011/main" val="1"/>
+            </a:ext>
+          </a:extLst>
         </p:spPr>
         <p:txBody>
-          <a:bodyPr/>
+          <a:bodyPr wrap="none" lIns="45718" tIns="45718" rIns="45718" bIns="45718">
+            <a:spAutoFit/>
+          </a:bodyPr>
           <a:lstStyle/>
           <a:p>
             <a:pPr/>
             <a:r>
-              <a:t>Data relationships</a:t>
+              <a:rPr sz="2300"/>
+              <a:t>Columns with highest correlation:</a:t>
+            </a:r>
+            <a:endParaRPr sz="2300"/>
+          </a:p>
+          <a:p>
+            <a:pPr/>
+            <a:r>
+              <a:t> </a:t>
             </a:r>
           </a:p>
         </p:txBody>
       </p:sp>
       <p:sp>
         <p:nvSpPr>
-          <p:cNvPr id="83" name="Textplatzhalter 2"/>
+          <p:cNvPr id="97" name="Columns with no significant correlation…"/>
           <p:cNvSpPr txBox="1"/>
-          <p:nvPr>
-            <p:ph type="body" sz="quarter" idx="1"/>
-          </p:nvPr>
+          <p:nvPr/>
         </p:nvSpPr>
         <p:spPr>
           <a:xfrm>
-            <a:off x="880588" y="349997"/>
-            <a:ext cx="10187500" cy="286721"/>
+            <a:off x="740415" y="4201805"/>
+            <a:ext cx="5101527" cy="1704339"/>
           </a:xfrm>
           <a:prstGeom prst="rect">
             <a:avLst/>
           </a:prstGeom>
+          <a:ln w="12700">
+            <a:miter lim="400000"/>
+          </a:ln>
+          <a:extLst>
+            <a:ext uri="{C572A759-6A51-4108-AA02-DFA0A04FC94B}">
+              <ma14:wrappingTextBoxFlag xmlns:ma14="http://schemas.microsoft.com/office/mac/drawingml/2011/main" val="1"/>
+            </a:ext>
+          </a:extLst>
         </p:spPr>
         <p:txBody>
-          <a:bodyPr/>
+          <a:bodyPr wrap="none" lIns="45718" tIns="45718" rIns="45718" bIns="45718">
+            <a:spAutoFit/>
+          </a:bodyPr>
           <a:lstStyle/>
           <a:p>
-            <a:pPr/>
+            <a:pPr>
+              <a:defRPr sz="2200"/>
+            </a:pPr>
+            <a:r>
+              <a:t>Columns with no significant correlation </a:t>
+            </a:r>
+          </a:p>
+          <a:p>
+            <a:pPr>
+              <a:defRPr sz="2200"/>
+            </a:pPr>
+            <a:r>
+              <a:t>that seemed surprising:</a:t>
+            </a:r>
+          </a:p>
+          <a:p>
+            <a:pPr marL="260684" indent="-260684">
+              <a:buSzPct val="100000"/>
+              <a:buChar char="•"/>
+              <a:defRPr sz="2200"/>
+            </a:pPr>
+            <a:r>
+              <a:t>Power play time and Power play goals</a:t>
+            </a:r>
+          </a:p>
+          <a:p>
+            <a:pPr marL="260684" indent="-260684">
+              <a:buSzPct val="100000"/>
+              <a:buChar char="•"/>
+              <a:defRPr sz="2200"/>
+            </a:pPr>
+            <a:r>
+              <a:t>Years played and salary</a:t>
+            </a:r>
+            <a:endParaRPr sz="1900"/>
           </a:p>
         </p:txBody>
       </p:sp>
@@ -3028,31 +4496,39 @@
       </p:grpSpPr>
       <p:sp>
         <p:nvSpPr>
-          <p:cNvPr id="85" name="Data cleaning"/>
+          <p:cNvPr id="99" name="Data relationship"/>
           <p:cNvSpPr txBox="1"/>
           <p:nvPr>
             <p:ph type="title"/>
           </p:nvPr>
         </p:nvSpPr>
         <p:spPr>
+          <a:xfrm>
+            <a:off x="880588" y="884237"/>
+            <a:ext cx="3096624" cy="614118"/>
+          </a:xfrm>
           <a:prstGeom prst="rect">
             <a:avLst/>
           </a:prstGeom>
         </p:spPr>
         <p:txBody>
           <a:bodyPr/>
-          <a:lstStyle/>
+          <a:lstStyle>
+            <a:lvl1pPr defTabSz="615675">
+              <a:defRPr sz="3230"/>
+            </a:lvl1pPr>
+          </a:lstStyle>
           <a:p>
             <a:pPr/>
             <a:r>
-              <a:t>Data cleaning</a:t>
+              <a:t>Data relationship</a:t>
             </a:r>
           </a:p>
         </p:txBody>
       </p:sp>
       <p:sp>
         <p:nvSpPr>
-          <p:cNvPr id="86" name="Zum Bearbeiten doppelklicken"/>
+          <p:cNvPr id="100" name="Zum Bearbeiten doppelklicken"/>
           <p:cNvSpPr txBox="1"/>
           <p:nvPr>
             <p:ph type="body" sz="quarter" idx="1"/>
@@ -3068,246 +4544,6 @@
           <a:lstStyle/>
           <a:p>
             <a:pPr/>
-          </a:p>
-        </p:txBody>
-      </p:sp>
-      <p:sp>
-        <p:nvSpPr>
-          <p:cNvPr id="87" name="Foliennummer"/>
-          <p:cNvSpPr txBox="1"/>
-          <p:nvPr>
-            <p:ph type="sldNum" sz="quarter" idx="2"/>
-          </p:nvPr>
-        </p:nvSpPr>
-        <p:spPr>
-          <a:xfrm>
-            <a:off x="241984" y="924083"/>
-            <a:ext cx="127001" cy="197384"/>
-          </a:xfrm>
-          <a:prstGeom prst="rect">
-            <a:avLst/>
-          </a:prstGeom>
-          <a:extLst>
-            <a:ext uri="{C572A759-6A51-4108-AA02-DFA0A04FC94B}">
-              <ma14:wrappingTextBoxFlag xmlns:ma14="http://schemas.microsoft.com/office/mac/drawingml/2011/main" val="1"/>
-            </a:ext>
-          </a:extLst>
-        </p:spPr>
-        <p:txBody>
-          <a:bodyPr/>
-          <a:lstStyle/>
-          <a:p>
-            <a:pPr/>
-            <a:fld id="{86CB4B4D-7CA3-9044-876B-883B54F8677D}" type="slidenum"/>
-          </a:p>
-        </p:txBody>
-      </p:sp>
-      <p:sp>
-        <p:nvSpPr>
-          <p:cNvPr id="88" name="We first looked at each Dataset separately to identify problems:…"/>
-          <p:cNvSpPr txBox="1"/>
-          <p:nvPr/>
-        </p:nvSpPr>
-        <p:spPr>
-          <a:xfrm>
-            <a:off x="196729" y="1663700"/>
-            <a:ext cx="12969241" cy="4521201"/>
-          </a:xfrm>
-          <a:prstGeom prst="rect">
-            <a:avLst/>
-          </a:prstGeom>
-          <a:ln w="12700">
-            <a:miter lim="400000"/>
-          </a:ln>
-          <a:extLst>
-            <a:ext uri="{C572A759-6A51-4108-AA02-DFA0A04FC94B}">
-              <ma14:wrappingTextBoxFlag xmlns:ma14="http://schemas.microsoft.com/office/mac/drawingml/2011/main" val="1"/>
-            </a:ext>
-          </a:extLst>
-        </p:spPr>
-        <p:txBody>
-          <a:bodyPr wrap="none" lIns="45719" rIns="45719">
-            <a:spAutoFit/>
-          </a:bodyPr>
-          <a:lstStyle/>
-          <a:p>
-            <a:pPr/>
-            <a:r>
-              <a:t>We first looked at each Dataset separately to identify problems:</a:t>
-            </a:r>
-          </a:p>
-          <a:p>
-            <a:pPr marL="228600" indent="-228600" defTabSz="914400">
-              <a:lnSpc>
-                <a:spcPct val="90000"/>
-              </a:lnSpc>
-              <a:spcBef>
-                <a:spcPts val="1000"/>
-              </a:spcBef>
-              <a:buSzPct val="100000"/>
-              <a:buFont typeface="Arial"/>
-              <a:buChar char="•"/>
-              <a:defRPr sz="2400">
-                <a:latin typeface="Aptos"/>
-                <a:ea typeface="Aptos"/>
-                <a:cs typeface="Aptos"/>
-                <a:sym typeface="Aptos"/>
-              </a:defRPr>
-            </a:pPr>
-            <a:r>
-              <a:t>Identity_card: </a:t>
-            </a:r>
-          </a:p>
-          <a:p>
-            <a:pPr lvl="1" marL="685800" indent="-228600" defTabSz="914400">
-              <a:lnSpc>
-                <a:spcPct val="90000"/>
-              </a:lnSpc>
-              <a:spcBef>
-                <a:spcPts val="1000"/>
-              </a:spcBef>
-              <a:buSzPct val="100000"/>
-              <a:buFont typeface="Arial"/>
-              <a:buChar char="•"/>
-              <a:defRPr sz="2400">
-                <a:latin typeface="Aptos"/>
-                <a:ea typeface="Aptos"/>
-                <a:cs typeface="Aptos"/>
-                <a:sym typeface="Aptos"/>
-              </a:defRPr>
-            </a:pPr>
-            <a:r>
-              <a:t>birth city and nationality often didn’t match, for clarity decided to drop birth city since </a:t>
-            </a:r>
-          </a:p>
-          <a:p>
-            <a:pPr lvl="3" indent="685800" defTabSz="914400">
-              <a:lnSpc>
-                <a:spcPct val="90000"/>
-              </a:lnSpc>
-              <a:spcBef>
-                <a:spcPts val="1000"/>
-              </a:spcBef>
-              <a:defRPr sz="2400">
-                <a:latin typeface="Aptos"/>
-                <a:ea typeface="Aptos"/>
-                <a:cs typeface="Aptos"/>
-                <a:sym typeface="Aptos"/>
-              </a:defRPr>
-            </a:pPr>
-            <a:r>
-              <a:t>nationality is more important for player visas etc. </a:t>
-            </a:r>
-          </a:p>
-          <a:p>
-            <a:pPr lvl="1" marL="685800" indent="-228600" defTabSz="914400">
-              <a:lnSpc>
-                <a:spcPct val="90000"/>
-              </a:lnSpc>
-              <a:spcBef>
-                <a:spcPts val="1000"/>
-              </a:spcBef>
-              <a:buSzPct val="100000"/>
-              <a:buFont typeface="Arial"/>
-              <a:buChar char="•"/>
-              <a:defRPr sz="2400">
-                <a:latin typeface="Aptos"/>
-                <a:ea typeface="Aptos"/>
-                <a:cs typeface="Aptos"/>
-                <a:sym typeface="Aptos"/>
-              </a:defRPr>
-            </a:pPr>
-            <a:r>
-              <a:t>Age outliers found upon inspection, some even ≈300 years old, decided on the upper bound of 122 for the oldest person alive on earth </a:t>
-            </a:r>
-          </a:p>
-          <a:p>
-            <a:pPr marL="228600" indent="-228600" defTabSz="914400">
-              <a:lnSpc>
-                <a:spcPct val="90000"/>
-              </a:lnSpc>
-              <a:spcBef>
-                <a:spcPts val="1000"/>
-              </a:spcBef>
-              <a:buSzPct val="100000"/>
-              <a:buFont typeface="Arial"/>
-              <a:buChar char="•"/>
-              <a:defRPr sz="2400">
-                <a:latin typeface="Aptos"/>
-                <a:ea typeface="Aptos"/>
-                <a:cs typeface="Aptos"/>
-                <a:sym typeface="Aptos"/>
-              </a:defRPr>
-            </a:pPr>
-            <a:r>
-              <a:t>Scouting notes:</a:t>
-            </a:r>
-          </a:p>
-          <a:p>
-            <a:pPr lvl="1" marL="685800" indent="-228600" defTabSz="914400">
-              <a:lnSpc>
-                <a:spcPct val="90000"/>
-              </a:lnSpc>
-              <a:spcBef>
-                <a:spcPts val="1000"/>
-              </a:spcBef>
-              <a:buSzPct val="100000"/>
-              <a:buFont typeface="Arial"/>
-              <a:buChar char="•"/>
-              <a:defRPr sz="2400">
-                <a:latin typeface="Aptos"/>
-                <a:ea typeface="Aptos"/>
-                <a:cs typeface="Aptos"/>
-                <a:sym typeface="Aptos"/>
-              </a:defRPr>
-            </a:pPr>
-            <a:r>
-              <a:t>Some players had more years pro than years played in general, decided to drop those</a:t>
-            </a:r>
-          </a:p>
-          <a:p>
-            <a:pPr lvl="1" marL="685800" indent="-228600" defTabSz="914400">
-              <a:lnSpc>
-                <a:spcPct val="90000"/>
-              </a:lnSpc>
-              <a:spcBef>
-                <a:spcPts val="1000"/>
-              </a:spcBef>
-              <a:buSzPct val="100000"/>
-              <a:buFont typeface="Arial"/>
-              <a:buChar char="•"/>
-              <a:defRPr sz="2400">
-                <a:latin typeface="Aptos"/>
-                <a:ea typeface="Aptos"/>
-                <a:cs typeface="Aptos"/>
-                <a:sym typeface="Aptos"/>
-              </a:defRPr>
-            </a:pPr>
-            <a:r>
-              <a:t>Dropped players with 0 years of experience but experience level over a rookie </a:t>
-            </a:r>
-          </a:p>
-          <a:p>
-            <a:pPr lvl="1" marL="685800" indent="-228600" defTabSz="914400">
-              <a:lnSpc>
-                <a:spcPct val="90000"/>
-              </a:lnSpc>
-              <a:spcBef>
-                <a:spcPts val="1000"/>
-              </a:spcBef>
-              <a:buSzPct val="100000"/>
-              <a:buFont typeface="Arial"/>
-              <a:buChar char="•"/>
-              <a:defRPr sz="2400">
-                <a:latin typeface="Aptos"/>
-                <a:ea typeface="Aptos"/>
-                <a:cs typeface="Aptos"/>
-                <a:sym typeface="Aptos"/>
-              </a:defRPr>
-            </a:pPr>
-            <a:r>
-              <a:t>Filled NaN values for scout notes with „no notes“ and for dominant hand with „none“</a:t>
-            </a:r>
           </a:p>
         </p:txBody>
       </p:sp>
@@ -3339,20 +4575,28 @@
       </p:grpSpPr>
       <p:sp>
         <p:nvSpPr>
-          <p:cNvPr id="90" name="Data cleaning"/>
+          <p:cNvPr id="102" name="Data cleaning"/>
           <p:cNvSpPr txBox="1"/>
           <p:nvPr>
             <p:ph type="title"/>
           </p:nvPr>
         </p:nvSpPr>
         <p:spPr>
+          <a:xfrm>
+            <a:off x="880588" y="884237"/>
+            <a:ext cx="2581075" cy="614118"/>
+          </a:xfrm>
           <a:prstGeom prst="rect">
             <a:avLst/>
           </a:prstGeom>
         </p:spPr>
         <p:txBody>
           <a:bodyPr/>
-          <a:lstStyle/>
+          <a:lstStyle>
+            <a:lvl1pPr defTabSz="628637">
+              <a:defRPr sz="3298"/>
+            </a:lvl1pPr>
+          </a:lstStyle>
           <a:p>
             <a:pPr/>
             <a:r>
@@ -3363,7 +4607,7 @@
       </p:sp>
       <p:sp>
         <p:nvSpPr>
-          <p:cNvPr id="91" name="Zum Bearbeiten doppelklicken"/>
+          <p:cNvPr id="103" name="Zum Bearbeiten doppelklicken"/>
           <p:cNvSpPr txBox="1"/>
           <p:nvPr>
             <p:ph type="body" sz="quarter" idx="1"/>
@@ -3384,20 +4628,21 @@
       </p:sp>
       <p:sp>
         <p:nvSpPr>
-          <p:cNvPr id="92" name="Foliennummer"/>
+          <p:cNvPr id="104" name="Columns drop due to inconsistency with others:…"/>
           <p:cNvSpPr txBox="1"/>
-          <p:nvPr>
-            <p:ph type="sldNum" sz="quarter" idx="2"/>
-          </p:nvPr>
+          <p:nvPr/>
         </p:nvSpPr>
         <p:spPr>
           <a:xfrm>
-            <a:off x="241984" y="924083"/>
-            <a:ext cx="127001" cy="197384"/>
+            <a:off x="860814" y="1745873"/>
+            <a:ext cx="11227416" cy="5996939"/>
           </a:xfrm>
           <a:prstGeom prst="rect">
             <a:avLst/>
           </a:prstGeom>
+          <a:ln w="12700">
+            <a:miter lim="400000"/>
+          </a:ln>
           <a:extLst>
             <a:ext uri="{C572A759-6A51-4108-AA02-DFA0A04FC94B}">
               <ma14:wrappingTextBoxFlag xmlns:ma14="http://schemas.microsoft.com/office/mac/drawingml/2011/main" val="1"/>
@@ -3405,11 +4650,120 @@
           </a:extLst>
         </p:spPr>
         <p:txBody>
-          <a:bodyPr/>
+          <a:bodyPr wrap="none" lIns="45718" tIns="45718" rIns="45718" bIns="45718">
+            <a:spAutoFit/>
+          </a:bodyPr>
           <a:lstStyle/>
           <a:p>
+            <a:pPr marL="260684" indent="-260684">
+              <a:buSzPct val="100000"/>
+              <a:buChar char="•"/>
+            </a:pPr>
+            <a:r>
+              <a:t>Columns drop due to inconsistency with others:</a:t>
+            </a:r>
+          </a:p>
+          <a:p>
+            <a:pPr lvl="1" marL="641684" indent="-260684">
+              <a:buSzPct val="100000"/>
+              <a:buChar char="•"/>
+            </a:pPr>
+            <a:r>
+              <a:t>Birth city </a:t>
+            </a:r>
+          </a:p>
+          <a:p>
+            <a:pPr lvl="1" marL="641684" indent="-260684">
+              <a:buSzPct val="100000"/>
+              <a:buChar char="•"/>
+            </a:pPr>
+            <a:r>
+              <a:t>Puck touches</a:t>
+            </a:r>
+          </a:p>
+          <a:p>
+            <a:pPr lvl="1" marL="641684" indent="-260684">
+              <a:buSzPct val="100000"/>
+              <a:buChar char="•"/>
+            </a:pPr>
+            <a:r>
+              <a:t>Time between penalties </a:t>
+            </a:r>
+          </a:p>
+          <a:p>
+            <a:pPr lvl="1" marL="641684" indent="-260684">
+              <a:buSzPct val="100000"/>
+              <a:buChar char="•"/>
+            </a:pPr>
+            <a:r>
+              <a:t>Goals total</a:t>
+            </a:r>
+          </a:p>
+          <a:p>
             <a:pPr/>
-            <a:fld id="{86CB4B4D-7CA3-9044-876B-883B54F8677D}" type="slidenum"/>
+          </a:p>
+          <a:p>
+            <a:pPr marL="260684" indent="-260684">
+              <a:buSzPct val="100000"/>
+              <a:buChar char="•"/>
+            </a:pPr>
+            <a:r>
+              <a:t>Rows dropped due to conflicting values:</a:t>
+            </a:r>
+          </a:p>
+          <a:p>
+            <a:pPr lvl="1" marL="641684" indent="-260684">
+              <a:buSzPct val="100000"/>
+              <a:buChar char="•"/>
+            </a:pPr>
+            <a:r>
+              <a:t>Players with more years pro than years played</a:t>
+            </a:r>
+          </a:p>
+          <a:p>
+            <a:pPr lvl="1" marL="641684" indent="-260684">
+              <a:buSzPct val="100000"/>
+              <a:buChar char="•"/>
+            </a:pPr>
+            <a:r>
+              <a:t>0 years of experience but level higher than a rookie</a:t>
+            </a:r>
+          </a:p>
+          <a:p>
+            <a:pPr lvl="1" marL="641684" indent="-260684">
+              <a:buSzPct val="100000"/>
+              <a:buChar char="•"/>
+            </a:pPr>
+            <a:r>
+              <a:t>Age outliers, upper bound decided by oldest person alive on earth (122)</a:t>
+            </a:r>
+          </a:p>
+          <a:p>
+            <a:pPr lvl="1" marL="641684" indent="-260684">
+              <a:buSzPct val="100000"/>
+              <a:buChar char="•"/>
+            </a:pPr>
+            <a:r>
+              <a:t>Draft year before 1922</a:t>
+            </a:r>
+          </a:p>
+          <a:p>
+            <a:pPr lvl="1" marL="641684" indent="-260684">
+              <a:buSzPct val="100000"/>
+              <a:buChar char="•"/>
+            </a:pPr>
+          </a:p>
+          <a:p>
+            <a:pPr lvl="1" marL="641684" indent="-260684">
+              <a:buSzPct val="100000"/>
+              <a:buChar char="•"/>
+            </a:pPr>
+          </a:p>
+          <a:p>
+            <a:pPr lvl="1" marL="641684" indent="-260684">
+              <a:buSzPct val="100000"/>
+              <a:buChar char="•"/>
+            </a:pPr>
           </a:p>
         </p:txBody>
       </p:sp>
@@ -3441,7 +4795,7 @@
       </p:grpSpPr>
       <p:sp>
         <p:nvSpPr>
-          <p:cNvPr id="94" name="Most important findings"/>
+          <p:cNvPr id="106" name="Data cleaning"/>
           <p:cNvSpPr txBox="1"/>
           <p:nvPr>
             <p:ph type="title"/>
@@ -3458,14 +4812,14 @@
           <a:p>
             <a:pPr/>
             <a:r>
-              <a:t>Most important findings</a:t>
+              <a:t>Data cleaning </a:t>
             </a:r>
           </a:p>
         </p:txBody>
       </p:sp>
       <p:sp>
         <p:nvSpPr>
-          <p:cNvPr id="95" name="Zum Bearbeiten doppelklicken"/>
+          <p:cNvPr id="107" name="Zum Bearbeiten doppelklicken"/>
           <p:cNvSpPr txBox="1"/>
           <p:nvPr>
             <p:ph type="body" sz="quarter" idx="1"/>
@@ -3486,16 +4840,186 @@
       </p:sp>
       <p:sp>
         <p:nvSpPr>
-          <p:cNvPr id="96" name="Foliennummer"/>
+          <p:cNvPr id="108" name="Additional actions taken:…"/>
+          <p:cNvSpPr txBox="1"/>
+          <p:nvPr/>
+        </p:nvSpPr>
+        <p:spPr>
+          <a:xfrm>
+            <a:off x="912271" y="1745873"/>
+            <a:ext cx="9620718" cy="2847339"/>
+          </a:xfrm>
+          <a:prstGeom prst="rect">
+            <a:avLst/>
+          </a:prstGeom>
+          <a:ln w="12700">
+            <a:miter lim="400000"/>
+          </a:ln>
+          <a:extLst>
+            <a:ext uri="{C572A759-6A51-4108-AA02-DFA0A04FC94B}">
+              <ma14:wrappingTextBoxFlag xmlns:ma14="http://schemas.microsoft.com/office/mac/drawingml/2011/main" val="1"/>
+            </a:ext>
+          </a:extLst>
+        </p:spPr>
+        <p:txBody>
+          <a:bodyPr wrap="none" lIns="45718" tIns="45718" rIns="45718" bIns="45718">
+            <a:spAutoFit/>
+          </a:bodyPr>
+          <a:lstStyle/>
+          <a:p>
+            <a:pPr/>
+            <a:r>
+              <a:t>Additional actions taken:</a:t>
+            </a:r>
+          </a:p>
+          <a:p>
+            <a:pPr marL="260684" indent="-260684">
+              <a:buSzPct val="100000"/>
+              <a:buChar char="•"/>
+            </a:pPr>
+            <a:r>
+              <a:t>Filled NaN values</a:t>
+            </a:r>
+          </a:p>
+          <a:p>
+            <a:pPr marL="260684" indent="-260684">
+              <a:buSzPct val="100000"/>
+              <a:buChar char="•"/>
+            </a:pPr>
+            <a:r>
+              <a:t>Set penalty time to 0 for players without any penalties</a:t>
+            </a:r>
+          </a:p>
+          <a:p>
+            <a:pPr marL="260684" indent="-260684">
+              <a:buSzPct val="100000"/>
+              <a:buChar char="•"/>
+            </a:pPr>
+            <a:r>
+              <a:t>Puck possession time reformatted from minutes to seconds</a:t>
+            </a:r>
+          </a:p>
+          <a:p>
+            <a:pPr marL="260684" indent="-260684">
+              <a:buSzPct val="100000"/>
+              <a:buChar char="•"/>
+            </a:pPr>
+            <a:r>
+              <a:t>Newly calculated shooting percentage</a:t>
+            </a:r>
+          </a:p>
+          <a:p>
+            <a:pPr lvl="2" indent="457200"/>
+            <a:r>
+              <a:t>Equation: shooting_percentage = goals/ number of shots *100</a:t>
+            </a:r>
+          </a:p>
+          <a:p>
+            <a:pPr marL="260684" indent="-260684">
+              <a:buSzPct val="100000"/>
+              <a:buChar char="•"/>
+            </a:pPr>
+            <a:r>
+              <a:t> </a:t>
+            </a:r>
+          </a:p>
+        </p:txBody>
+      </p:sp>
+    </p:spTree>
+  </p:cSld>
+  <p:clrMapOvr>
+    <a:masterClrMapping/>
+  </p:clrMapOvr>
+  <p:transition xmlns:p14="http://schemas.microsoft.com/office/powerpoint/2010/main" spd="med" advClick="1"/>
+</p:sld>
+</file>
+
+<file path=ppt/slides/slide9.xml><?xml version="1.0" encoding="utf-8"?>
+<p:sld xmlns:a="http://schemas.openxmlformats.org/drawingml/2006/main" xmlns:r="http://schemas.openxmlformats.org/officeDocument/2006/relationships" xmlns:p="http://schemas.openxmlformats.org/presentationml/2006/main" xmlns:m="http://schemas.openxmlformats.org/officeDocument/2006/math" xmlns:a14="http://schemas.microsoft.com/office/drawing/2010/main" show="0" showMasterSp="1" showMasterPhAnim="1">
+  <p:cSld>
+    <p:spTree>
+      <p:nvGrpSpPr>
+        <p:cNvPr id="1" name=""/>
+        <p:cNvGrpSpPr/>
+        <p:nvPr/>
+      </p:nvGrpSpPr>
+      <p:grpSpPr>
+        <a:xfrm>
+          <a:off x="0" y="0"/>
+          <a:ext cx="0" cy="0"/>
+          <a:chOff x="0" y="0"/>
+          <a:chExt cx="0" cy="0"/>
+        </a:xfrm>
+      </p:grpSpPr>
+      <p:sp>
+        <p:nvSpPr>
+          <p:cNvPr id="110" name="Data cleaning"/>
           <p:cNvSpPr txBox="1"/>
           <p:nvPr>
-            <p:ph type="sldNum" sz="quarter" idx="2"/>
+            <p:ph type="title"/>
           </p:nvPr>
         </p:nvSpPr>
         <p:spPr>
+          <a:prstGeom prst="rect">
+            <a:avLst/>
+          </a:prstGeom>
+        </p:spPr>
+        <p:txBody>
+          <a:bodyPr/>
+          <a:lstStyle>
+            <a:lvl1pPr>
+              <a:defRPr>
+                <a:solidFill>
+                  <a:srgbClr val="040102"/>
+                </a:solidFill>
+              </a:defRPr>
+            </a:lvl1pPr>
+          </a:lstStyle>
+          <a:p>
+            <a:pPr/>
+            <a:r>
+              <a:t>Data cleaning</a:t>
+            </a:r>
+          </a:p>
+        </p:txBody>
+      </p:sp>
+      <p:sp>
+        <p:nvSpPr>
+          <p:cNvPr id="111" name="Zum Bearbeiten doppelklicken"/>
+          <p:cNvSpPr txBox="1"/>
+          <p:nvPr>
+            <p:ph type="body" sz="quarter" idx="1"/>
+          </p:nvPr>
+        </p:nvSpPr>
+        <p:spPr>
           <a:xfrm>
-            <a:off x="241984" y="924083"/>
-            <a:ext cx="127001" cy="197384"/>
+            <a:off x="880588" y="349996"/>
+            <a:ext cx="10187500" cy="286723"/>
+          </a:xfrm>
+          <a:prstGeom prst="rect">
+            <a:avLst/>
+          </a:prstGeom>
+        </p:spPr>
+        <p:txBody>
+          <a:bodyPr/>
+          <a:lstStyle/>
+          <a:p>
+            <a:pPr/>
+          </a:p>
+        </p:txBody>
+      </p:sp>
+      <p:sp>
+        <p:nvSpPr>
+          <p:cNvPr id="112" name="Foliennummer"/>
+          <p:cNvSpPr txBox="1"/>
+          <p:nvPr>
+            <p:ph type="sldNum" sz="quarter" idx="4294967295"/>
+          </p:nvPr>
+        </p:nvSpPr>
+        <p:spPr>
+          <a:xfrm>
+            <a:off x="239838" y="924083"/>
+            <a:ext cx="131293" cy="197384"/>
           </a:xfrm>
           <a:prstGeom prst="rect">
             <a:avLst/>
@@ -3512,6 +5036,244 @@
           <a:p>
             <a:pPr/>
             <a:fld id="{86CB4B4D-7CA3-9044-876B-883B54F8677D}" type="slidenum"/>
+          </a:p>
+        </p:txBody>
+      </p:sp>
+      <p:sp>
+        <p:nvSpPr>
+          <p:cNvPr id="113" name="We first looked at each Dataset separately to identify problems:…"/>
+          <p:cNvSpPr txBox="1"/>
+          <p:nvPr/>
+        </p:nvSpPr>
+        <p:spPr>
+          <a:xfrm>
+            <a:off x="196729" y="1663700"/>
+            <a:ext cx="11914128" cy="4518659"/>
+          </a:xfrm>
+          <a:prstGeom prst="rect">
+            <a:avLst/>
+          </a:prstGeom>
+          <a:ln w="12700">
+            <a:miter lim="400000"/>
+          </a:ln>
+          <a:extLst>
+            <a:ext uri="{C572A759-6A51-4108-AA02-DFA0A04FC94B}">
+              <ma14:wrappingTextBoxFlag xmlns:ma14="http://schemas.microsoft.com/office/mac/drawingml/2011/main" val="1"/>
+            </a:ext>
+          </a:extLst>
+        </p:spPr>
+        <p:txBody>
+          <a:bodyPr wrap="none" lIns="45718" tIns="45718" rIns="45718" bIns="45718">
+            <a:spAutoFit/>
+          </a:bodyPr>
+          <a:lstStyle/>
+          <a:p>
+            <a:pPr>
+              <a:defRPr sz="2500">
+                <a:latin typeface="Arial"/>
+                <a:ea typeface="Arial"/>
+                <a:cs typeface="Arial"/>
+                <a:sym typeface="Arial"/>
+              </a:defRPr>
+            </a:pPr>
+            <a:r>
+              <a:t>For easier comprehension split up into the original datasets</a:t>
+            </a:r>
+          </a:p>
+          <a:p>
+            <a:pPr marL="228600" indent="-228600" defTabSz="914400">
+              <a:lnSpc>
+                <a:spcPct val="90000"/>
+              </a:lnSpc>
+              <a:spcBef>
+                <a:spcPts val="1000"/>
+              </a:spcBef>
+              <a:buSzPct val="100000"/>
+              <a:buFont typeface="Arial"/>
+              <a:buChar char="•"/>
+              <a:defRPr sz="2300">
+                <a:latin typeface="Aptos"/>
+                <a:ea typeface="Aptos"/>
+                <a:cs typeface="Aptos"/>
+                <a:sym typeface="Aptos"/>
+              </a:defRPr>
+            </a:pPr>
+            <a:r>
+              <a:t>Identity_card: </a:t>
+            </a:r>
+          </a:p>
+          <a:p>
+            <a:pPr lvl="1" marL="685800" indent="-228600" defTabSz="914400">
+              <a:lnSpc>
+                <a:spcPct val="90000"/>
+              </a:lnSpc>
+              <a:spcBef>
+                <a:spcPts val="1000"/>
+              </a:spcBef>
+              <a:buSzPct val="100000"/>
+              <a:buFont typeface="Arial"/>
+              <a:buChar char="•"/>
+              <a:defRPr sz="2300">
+                <a:latin typeface="Aptos"/>
+                <a:ea typeface="Aptos"/>
+                <a:cs typeface="Aptos"/>
+                <a:sym typeface="Aptos"/>
+              </a:defRPr>
+            </a:pPr>
+            <a:r>
+              <a:t>birth city and nationality often didn’t match, birth city dropped due to </a:t>
+            </a:r>
+          </a:p>
+          <a:p>
+            <a:pPr lvl="3" indent="685800" defTabSz="914400">
+              <a:lnSpc>
+                <a:spcPct val="90000"/>
+              </a:lnSpc>
+              <a:spcBef>
+                <a:spcPts val="1000"/>
+              </a:spcBef>
+              <a:defRPr sz="2300">
+                <a:latin typeface="Aptos"/>
+                <a:ea typeface="Aptos"/>
+                <a:cs typeface="Aptos"/>
+                <a:sym typeface="Aptos"/>
+              </a:defRPr>
+            </a:pPr>
+            <a:r>
+              <a:t>higher relevance of nationality for player’s visas etc. </a:t>
+            </a:r>
+          </a:p>
+          <a:p>
+            <a:pPr lvl="1" marL="685800" indent="-228600" defTabSz="914400">
+              <a:lnSpc>
+                <a:spcPct val="90000"/>
+              </a:lnSpc>
+              <a:spcBef>
+                <a:spcPts val="1000"/>
+              </a:spcBef>
+              <a:buSzPct val="100000"/>
+              <a:buFont typeface="Arial"/>
+              <a:buChar char="•"/>
+              <a:defRPr sz="2300">
+                <a:latin typeface="Aptos"/>
+                <a:ea typeface="Aptos"/>
+                <a:cs typeface="Aptos"/>
+                <a:sym typeface="Aptos"/>
+              </a:defRPr>
+            </a:pPr>
+            <a:r>
+              <a:t>Age outliers found upon inspection, decided on the upper bound of 122 in reference to</a:t>
+            </a:r>
+          </a:p>
+          <a:p>
+            <a:pPr lvl="1" marL="685800" indent="-228600" defTabSz="914400">
+              <a:lnSpc>
+                <a:spcPct val="90000"/>
+              </a:lnSpc>
+              <a:spcBef>
+                <a:spcPts val="1000"/>
+              </a:spcBef>
+              <a:buSzPct val="100000"/>
+              <a:buFont typeface="Arial"/>
+              <a:buChar char="•"/>
+              <a:defRPr sz="2300">
+                <a:latin typeface="Aptos"/>
+                <a:ea typeface="Aptos"/>
+                <a:cs typeface="Aptos"/>
+                <a:sym typeface="Aptos"/>
+              </a:defRPr>
+            </a:pPr>
+            <a:r>
+              <a:t> the oldest person alive on earth</a:t>
+            </a:r>
+          </a:p>
+          <a:p>
+            <a:pPr marL="228600" indent="-228600" defTabSz="914400">
+              <a:lnSpc>
+                <a:spcPct val="90000"/>
+              </a:lnSpc>
+              <a:spcBef>
+                <a:spcPts val="1000"/>
+              </a:spcBef>
+              <a:buSzPct val="100000"/>
+              <a:buFont typeface="Arial"/>
+              <a:buChar char="•"/>
+              <a:defRPr sz="2300">
+                <a:latin typeface="Aptos"/>
+                <a:ea typeface="Aptos"/>
+                <a:cs typeface="Aptos"/>
+                <a:sym typeface="Aptos"/>
+              </a:defRPr>
+            </a:pPr>
+            <a:r>
+              <a:t>Scouting notes:</a:t>
+            </a:r>
+          </a:p>
+          <a:p>
+            <a:pPr lvl="1" marL="685800" indent="-228600" defTabSz="914400">
+              <a:lnSpc>
+                <a:spcPct val="90000"/>
+              </a:lnSpc>
+              <a:spcBef>
+                <a:spcPts val="1000"/>
+              </a:spcBef>
+              <a:buSzPct val="100000"/>
+              <a:buFont typeface="Arial"/>
+              <a:buChar char="•"/>
+              <a:defRPr sz="2300">
+                <a:latin typeface="Aptos"/>
+                <a:ea typeface="Aptos"/>
+                <a:cs typeface="Aptos"/>
+                <a:sym typeface="Aptos"/>
+              </a:defRPr>
+            </a:pPr>
+            <a:r>
+              <a:t>Some rows with more years pro than years played in general, these were dropped</a:t>
+            </a:r>
+          </a:p>
+          <a:p>
+            <a:pPr lvl="1" marL="685800" indent="-228600" defTabSz="914400">
+              <a:lnSpc>
+                <a:spcPct val="90000"/>
+              </a:lnSpc>
+              <a:spcBef>
+                <a:spcPts val="1000"/>
+              </a:spcBef>
+              <a:buSzPct val="100000"/>
+              <a:buFont typeface="Arial"/>
+              <a:buChar char="•"/>
+              <a:defRPr sz="2300">
+                <a:latin typeface="Aptos"/>
+                <a:ea typeface="Aptos"/>
+                <a:cs typeface="Aptos"/>
+                <a:sym typeface="Aptos"/>
+              </a:defRPr>
+            </a:pPr>
+            <a:r>
+              <a:t>Dropped players with 0 years of experience but experience level higher than rookie </a:t>
+            </a:r>
+          </a:p>
+          <a:p>
+            <a:pPr lvl="1" marL="685800" indent="-228600" defTabSz="914400">
+              <a:lnSpc>
+                <a:spcPct val="90000"/>
+              </a:lnSpc>
+              <a:spcBef>
+                <a:spcPts val="1000"/>
+              </a:spcBef>
+              <a:buSzPct val="100000"/>
+              <a:buFont typeface="Arial"/>
+              <a:buChar char="•"/>
+              <a:defRPr sz="2300">
+                <a:latin typeface="Aptos"/>
+                <a:ea typeface="Aptos"/>
+                <a:cs typeface="Aptos"/>
+                <a:sym typeface="Aptos"/>
+              </a:defRPr>
+            </a:pPr>
+            <a:r>
+              <a:t>Filled NaN values for scout notes with „no notes“ and for dominant hand with „none“</a:t>
+            </a:r>
           </a:p>
         </p:txBody>
       </p:sp>
@@ -3717,17 +5479,17 @@
         <a:solidFill>
           <a:srgbClr val="FFFFFF"/>
         </a:solidFill>
-        <a:ln w="12700" cap="flat">
+        <a:ln w="25400" cap="flat">
           <a:solidFill>
             <a:schemeClr val="accent1"/>
           </a:solidFill>
           <a:prstDash val="solid"/>
-          <a:miter lim="800000"/>
+          <a:round/>
         </a:ln>
         <a:effectLst/>
         <a:sp3d/>
       </a:spPr>
-      <a:bodyPr rot="0" spcFirstLastPara="1" vertOverflow="overflow" horzOverflow="overflow" vert="horz" wrap="square" lIns="45719" tIns="45719" rIns="45719" bIns="45719" numCol="1" spcCol="38100" rtlCol="0" anchor="ctr" upright="0">
+      <a:bodyPr rot="0" spcFirstLastPara="1" vertOverflow="overflow" horzOverflow="overflow" vert="horz" wrap="square" lIns="45718" tIns="45718" rIns="45718" bIns="45718" numCol="1" spcCol="38100" rtlCol="0" anchor="ctr" upright="0">
         <a:spAutoFit/>
       </a:bodyPr>
       <a:lstStyle>
@@ -3755,10 +5517,10 @@
             </a:solidFill>
             <a:effectLst/>
             <a:uFillTx/>
-            <a:latin typeface="Arial"/>
-            <a:ea typeface="Arial"/>
-            <a:cs typeface="Arial"/>
-            <a:sym typeface="Arial"/>
+            <a:latin typeface="+mn-lt"/>
+            <a:ea typeface="+mn-ea"/>
+            <a:cs typeface="+mn-cs"/>
+            <a:sym typeface="Helvetica"/>
           </a:defRPr>
         </a:defPPr>
         <a:lvl1pPr marL="0" marR="0" indent="0" algn="l" defTabSz="914400" rtl="0" fontAlgn="auto" latinLnBrk="1" hangingPunct="0">
@@ -4006,12 +5768,12 @@
     <a:lnDef>
       <a:spPr>
         <a:noFill/>
-        <a:ln w="12700" cap="flat">
+        <a:ln w="25400" cap="flat">
           <a:solidFill>
             <a:schemeClr val="accent1"/>
           </a:solidFill>
           <a:prstDash val="solid"/>
-          <a:miter lim="800000"/>
+          <a:round/>
         </a:ln>
         <a:effectLst/>
         <a:sp3d/>
@@ -4298,7 +6060,7 @@
         <a:effectLst/>
         <a:sp3d/>
       </a:spPr>
-      <a:bodyPr rot="0" spcFirstLastPara="1" vertOverflow="overflow" horzOverflow="overflow" vert="horz" wrap="square" lIns="45719" tIns="45719" rIns="45719" bIns="45719" numCol="1" spcCol="38100" rtlCol="0" anchor="t" upright="0">
+      <a:bodyPr rot="0" spcFirstLastPara="1" vertOverflow="overflow" horzOverflow="overflow" vert="horz" wrap="square" lIns="45718" tIns="45718" rIns="45718" bIns="45718" numCol="1" spcCol="38100" rtlCol="0" anchor="t" upright="0">
         <a:spAutoFit/>
       </a:bodyPr>
       <a:lstStyle>
@@ -4326,10 +6088,10 @@
             </a:solidFill>
             <a:effectLst/>
             <a:uFillTx/>
-            <a:latin typeface="Arial"/>
-            <a:ea typeface="Arial"/>
-            <a:cs typeface="Arial"/>
-            <a:sym typeface="Arial"/>
+            <a:latin typeface="+mn-lt"/>
+            <a:ea typeface="+mn-ea"/>
+            <a:cs typeface="+mn-cs"/>
+            <a:sym typeface="Helvetica"/>
           </a:defRPr>
         </a:defPPr>
         <a:lvl1pPr marL="0" marR="0" indent="0" algn="l" defTabSz="914400" rtl="0" fontAlgn="auto" latinLnBrk="1" hangingPunct="0">
@@ -4771,17 +6533,17 @@
         <a:solidFill>
           <a:srgbClr val="FFFFFF"/>
         </a:solidFill>
-        <a:ln w="12700" cap="flat">
+        <a:ln w="25400" cap="flat">
           <a:solidFill>
             <a:schemeClr val="accent1"/>
           </a:solidFill>
           <a:prstDash val="solid"/>
-          <a:miter lim="800000"/>
+          <a:round/>
         </a:ln>
         <a:effectLst/>
         <a:sp3d/>
       </a:spPr>
-      <a:bodyPr rot="0" spcFirstLastPara="1" vertOverflow="overflow" horzOverflow="overflow" vert="horz" wrap="square" lIns="45719" tIns="45719" rIns="45719" bIns="45719" numCol="1" spcCol="38100" rtlCol="0" anchor="ctr" upright="0">
+      <a:bodyPr rot="0" spcFirstLastPara="1" vertOverflow="overflow" horzOverflow="overflow" vert="horz" wrap="square" lIns="45718" tIns="45718" rIns="45718" bIns="45718" numCol="1" spcCol="38100" rtlCol="0" anchor="ctr" upright="0">
         <a:spAutoFit/>
       </a:bodyPr>
       <a:lstStyle>
@@ -4809,10 +6571,10 @@
             </a:solidFill>
             <a:effectLst/>
             <a:uFillTx/>
-            <a:latin typeface="Arial"/>
-            <a:ea typeface="Arial"/>
-            <a:cs typeface="Arial"/>
-            <a:sym typeface="Arial"/>
+            <a:latin typeface="+mn-lt"/>
+            <a:ea typeface="+mn-ea"/>
+            <a:cs typeface="+mn-cs"/>
+            <a:sym typeface="Helvetica"/>
           </a:defRPr>
         </a:defPPr>
         <a:lvl1pPr marL="0" marR="0" indent="0" algn="l" defTabSz="914400" rtl="0" fontAlgn="auto" latinLnBrk="1" hangingPunct="0">
@@ -5060,12 +6822,12 @@
     <a:lnDef>
       <a:spPr>
         <a:noFill/>
-        <a:ln w="12700" cap="flat">
+        <a:ln w="25400" cap="flat">
           <a:solidFill>
             <a:schemeClr val="accent1"/>
           </a:solidFill>
           <a:prstDash val="solid"/>
-          <a:miter lim="800000"/>
+          <a:round/>
         </a:ln>
         <a:effectLst/>
         <a:sp3d/>
@@ -5352,7 +7114,7 @@
         <a:effectLst/>
         <a:sp3d/>
       </a:spPr>
-      <a:bodyPr rot="0" spcFirstLastPara="1" vertOverflow="overflow" horzOverflow="overflow" vert="horz" wrap="square" lIns="45719" tIns="45719" rIns="45719" bIns="45719" numCol="1" spcCol="38100" rtlCol="0" anchor="t" upright="0">
+      <a:bodyPr rot="0" spcFirstLastPara="1" vertOverflow="overflow" horzOverflow="overflow" vert="horz" wrap="square" lIns="45718" tIns="45718" rIns="45718" bIns="45718" numCol="1" spcCol="38100" rtlCol="0" anchor="t" upright="0">
         <a:spAutoFit/>
       </a:bodyPr>
       <a:lstStyle>
@@ -5380,10 +7142,10 @@
             </a:solidFill>
             <a:effectLst/>
             <a:uFillTx/>
-            <a:latin typeface="Arial"/>
-            <a:ea typeface="Arial"/>
-            <a:cs typeface="Arial"/>
-            <a:sym typeface="Arial"/>
+            <a:latin typeface="+mn-lt"/>
+            <a:ea typeface="+mn-ea"/>
+            <a:cs typeface="+mn-cs"/>
+            <a:sym typeface="Helvetica"/>
           </a:defRPr>
         </a:defPPr>
         <a:lvl1pPr marL="0" marR="0" indent="0" algn="l" defTabSz="914400" rtl="0" fontAlgn="auto" latinLnBrk="1" hangingPunct="0">

</xml_diff>